<commit_message>
Restaurar animacao nativa do planejamento
</commit_message>
<xml_diff>
--- a/public/assets/modelo-base.pptx
+++ b/public/assets/modelo-base.pptx
@@ -4894,6 +4894,1927 @@
           <a:chExt cx="0" cy="0"/>
         </a:xfrm>
       </p:grpSpPr>
+      <p:pic>
+        <p:nvPicPr>
+          <p:cNvPr id="9" name="Imagem 8" descr="Uma imagem contendo escuro, mesa, luz, aceso&#10;&#10;Descrição gerada automaticamente">
+            <a:extLst>
+              <a:ext uri="{FF2B5EF4-FFF2-40B4-BE49-F238E27FC236}">
+                <a16:creationId xmlns:a16="http://schemas.microsoft.com/office/drawing/2014/main" id="{1C82D076-98FD-3973-669A-9980A3C28F4F}"/>
+              </a:ext>
+            </a:extLst>
+          </p:cNvPr>
+          <p:cNvPicPr>
+            <a:picLocks noChangeAspect="1"/>
+          </p:cNvPicPr>
+          <p:nvPr/>
+        </p:nvPicPr>
+        <p:blipFill rotWithShape="1">
+          <a:blip r:embed="rId3">
+            <a:extLst>
+              <a:ext uri="{28A0092B-C50C-407E-A947-70E740481C1C}">
+                <a14:useLocalDpi xmlns:a14="http://schemas.microsoft.com/office/drawing/2010/main" val="0"/>
+              </a:ext>
+            </a:extLst>
+          </a:blip>
+          <a:srcRect l="47191" t="1608" r="10113" b="12999"/>
+          <a:stretch>
+            <a:fillRect/>
+          </a:stretch>
+        </p:blipFill>
+        <p:spPr>
+          <a:xfrm>
+            <a:off x="-5429" y="0"/>
+            <a:ext cx="12192000" cy="6858000"/>
+          </a:xfrm>
+          <a:prstGeom prst="rect">
+            <a:avLst/>
+          </a:prstGeom>
+          <a:ln w="12700">
+            <a:noFill/>
+          </a:ln>
+        </p:spPr>
+      </p:pic>
+      <p:sp>
+        <p:nvSpPr>
+          <p:cNvPr id="2" name="CaixaDeTexto 1">
+            <a:extLst>
+              <a:ext uri="{FF2B5EF4-FFF2-40B4-BE49-F238E27FC236}">
+                <a16:creationId xmlns:a16="http://schemas.microsoft.com/office/drawing/2014/main" id="{80368641-9320-3FDD-4FA5-64A9D033E6D2}"/>
+              </a:ext>
+            </a:extLst>
+          </p:cNvPr>
+          <p:cNvSpPr txBox="1"/>
+          <p:nvPr/>
+        </p:nvSpPr>
+        <p:spPr>
+          <a:xfrm>
+            <a:off x="1588748" y="700909"/>
+            <a:ext cx="7863861" cy="605294"/>
+          </a:xfrm>
+          <a:prstGeom prst="rect">
+            <a:avLst/>
+          </a:prstGeom>
+          <a:noFill/>
+        </p:spPr>
+        <p:txBody>
+          <a:bodyPr wrap="square" rtlCol="0">
+            <a:spAutoFit/>
+          </a:bodyPr>
+          <a:lstStyle/>
+          <a:p>
+            <a:pPr>
+              <a:lnSpc>
+                <a:spcPts val="4000"/>
+              </a:lnSpc>
+              <a:tabLst>
+                <a:tab pos="2782888" algn="l"/>
+              </a:tabLst>
+            </a:pPr>
+            <a:r>
+              <a:rPr lang="da-DK" sz="4000" b="1" dirty="0">
+                <a:solidFill>
+                  <a:srgbClr val="FFFFFF"/>
+                </a:solidFill>
+                <a:latin typeface="GT America Bold" pitchFamily="2" charset="77"/>
+              </a:rPr>
+              <a:t>PLANEJAMENTO FINANCEIRO</a:t>
+            </a:r>
+            <a:endParaRPr lang="pt-BR" sz="3000" b="1" dirty="0">
+              <a:solidFill>
+                <a:srgbClr val="FFC971"/>
+              </a:solidFill>
+              <a:latin typeface="GT America Ultra Light" panose="00000300000000000000" pitchFamily="2" charset="0"/>
+            </a:endParaRPr>
+          </a:p>
+        </p:txBody>
+      </p:sp>
+      <p:sp>
+        <p:nvSpPr>
+          <p:cNvPr id="6" name="CaixaDeTexto 5">
+            <a:extLst>
+              <a:ext uri="{FF2B5EF4-FFF2-40B4-BE49-F238E27FC236}">
+                <a16:creationId xmlns:a16="http://schemas.microsoft.com/office/drawing/2014/main" id="{1EC681AD-20A2-C905-31E3-30C370372616}"/>
+              </a:ext>
+            </a:extLst>
+          </p:cNvPr>
+          <p:cNvSpPr txBox="1"/>
+          <p:nvPr/>
+        </p:nvSpPr>
+        <p:spPr>
+          <a:xfrm>
+            <a:off x="1609245" y="428519"/>
+            <a:ext cx="3495317" cy="263470"/>
+          </a:xfrm>
+          <a:prstGeom prst="rect">
+            <a:avLst/>
+          </a:prstGeom>
+          <a:noFill/>
+        </p:spPr>
+        <p:txBody>
+          <a:bodyPr wrap="square" rtlCol="0">
+            <a:spAutoFit/>
+          </a:bodyPr>
+          <a:lstStyle/>
+          <a:p>
+            <a:r>
+              <a:rPr lang="pt-BR" sz="1112" spc="600" dirty="0">
+                <a:solidFill>
+                  <a:srgbClr val="FFC971"/>
+                </a:solidFill>
+                <a:latin typeface="Lora" pitchFamily="2" charset="0"/>
+              </a:rPr>
+              <a:t>GESTÃO DE RISCOS</a:t>
+            </a:r>
+          </a:p>
+        </p:txBody>
+      </p:sp>
+      <p:cxnSp>
+        <p:nvCxnSpPr>
+          <p:cNvPr id="7" name="Conector Reto 3">
+            <a:extLst>
+              <a:ext uri="{FF2B5EF4-FFF2-40B4-BE49-F238E27FC236}">
+                <a16:creationId xmlns:a16="http://schemas.microsoft.com/office/drawing/2014/main" id="{B1B7C922-8DA4-B8B0-D46E-049F5D6F051D}"/>
+              </a:ext>
+            </a:extLst>
+          </p:cNvPr>
+          <p:cNvCxnSpPr>
+            <a:cxnSpLocks/>
+          </p:cNvCxnSpPr>
+          <p:nvPr/>
+        </p:nvCxnSpPr>
+        <p:spPr>
+          <a:xfrm flipV="1">
+            <a:off x="1181374" y="579120"/>
+            <a:ext cx="0" cy="6456041"/>
+          </a:xfrm>
+          <a:prstGeom prst="line">
+            <a:avLst/>
+          </a:prstGeom>
+          <a:ln>
+            <a:gradFill>
+              <a:gsLst>
+                <a:gs pos="100000">
+                  <a:srgbClr val="FFC971">
+                    <a:alpha val="0"/>
+                  </a:srgbClr>
+                </a:gs>
+                <a:gs pos="0">
+                  <a:srgbClr val="FFC971"/>
+                </a:gs>
+              </a:gsLst>
+              <a:lin ang="5400000" scaled="1"/>
+            </a:gradFill>
+          </a:ln>
+        </p:spPr>
+        <p:style>
+          <a:lnRef idx="1">
+            <a:schemeClr val="accent2"/>
+          </a:lnRef>
+          <a:fillRef idx="0">
+            <a:schemeClr val="accent2"/>
+          </a:fillRef>
+          <a:effectRef idx="0">
+            <a:schemeClr val="accent2"/>
+          </a:effectRef>
+          <a:fontRef idx="minor">
+            <a:schemeClr val="tx1"/>
+          </a:fontRef>
+        </p:style>
+      </p:cxnSp>
+      <p:grpSp>
+        <p:nvGrpSpPr>
+          <p:cNvPr id="89" name="Agrupar 88">
+            <a:extLst>
+              <a:ext uri="{FF2B5EF4-FFF2-40B4-BE49-F238E27FC236}">
+                <a16:creationId xmlns:a16="http://schemas.microsoft.com/office/drawing/2014/main" id="{2BB07DEC-2C80-6F23-7897-47BA3DBA78AC}"/>
+              </a:ext>
+            </a:extLst>
+          </p:cNvPr>
+          <p:cNvGrpSpPr/>
+          <p:nvPr/>
+        </p:nvGrpSpPr>
+        <p:grpSpPr>
+          <a:xfrm>
+            <a:off x="2414034" y="2116738"/>
+            <a:ext cx="3852688" cy="1267753"/>
+            <a:chOff x="2607074" y="2392335"/>
+            <a:chExt cx="3852688" cy="1267753"/>
+          </a:xfrm>
+        </p:grpSpPr>
+        <p:sp>
+          <p:nvSpPr>
+            <p:cNvPr id="78" name="Forma Livre: Forma 77">
+              <a:extLst>
+                <a:ext uri="{FF2B5EF4-FFF2-40B4-BE49-F238E27FC236}">
+                  <a16:creationId xmlns:a16="http://schemas.microsoft.com/office/drawing/2014/main" id="{9EE30414-F8D6-BA1C-D049-CC89DC66ACA6}"/>
+                </a:ext>
+              </a:extLst>
+            </p:cNvPr>
+            <p:cNvSpPr/>
+            <p:nvPr/>
+          </p:nvSpPr>
+          <p:spPr>
+            <a:xfrm rot="3415428" flipH="1">
+              <a:off x="5146554" y="2346880"/>
+              <a:ext cx="969688" cy="1656728"/>
+            </a:xfrm>
+            <a:custGeom>
+              <a:avLst/>
+              <a:gdLst>
+                <a:gd name="connsiteX0" fmla="*/ 780601 w 969688"/>
+                <a:gd name="connsiteY0" fmla="*/ 0 h 1656728"/>
+                <a:gd name="connsiteX1" fmla="*/ 0 w 969688"/>
+                <a:gd name="connsiteY1" fmla="*/ 508407 h 1656728"/>
+                <a:gd name="connsiteX2" fmla="*/ 86522 w 969688"/>
+                <a:gd name="connsiteY2" fmla="*/ 1266489 h 1656728"/>
+                <a:gd name="connsiteX3" fmla="*/ 969688 w 969688"/>
+                <a:gd name="connsiteY3" fmla="*/ 1656728 h 1656728"/>
+              </a:gdLst>
+              <a:ahLst/>
+              <a:cxnLst>
+                <a:cxn ang="0">
+                  <a:pos x="connsiteX0" y="connsiteY0"/>
+                </a:cxn>
+                <a:cxn ang="0">
+                  <a:pos x="connsiteX1" y="connsiteY1"/>
+                </a:cxn>
+                <a:cxn ang="0">
+                  <a:pos x="connsiteX2" y="connsiteY2"/>
+                </a:cxn>
+                <a:cxn ang="0">
+                  <a:pos x="connsiteX3" y="connsiteY3"/>
+                </a:cxn>
+              </a:cxnLst>
+              <a:rect l="l" t="t" r="r" b="b"/>
+              <a:pathLst>
+                <a:path w="969688" h="1656728">
+                  <a:moveTo>
+                    <a:pt x="780601" y="0"/>
+                  </a:moveTo>
+                  <a:lnTo>
+                    <a:pt x="0" y="508407"/>
+                  </a:lnTo>
+                  <a:lnTo>
+                    <a:pt x="86522" y="1266489"/>
+                  </a:lnTo>
+                  <a:lnTo>
+                    <a:pt x="969688" y="1656728"/>
+                  </a:lnTo>
+                  <a:close/>
+                </a:path>
+              </a:pathLst>
+            </a:custGeom>
+            <a:solidFill>
+              <a:schemeClr val="accent6">
+                <a:lumMod val="20000"/>
+                <a:lumOff val="80000"/>
+                <a:alpha val="30000"/>
+              </a:schemeClr>
+            </a:solidFill>
+            <a:ln>
+              <a:solidFill>
+                <a:srgbClr val="FFFFFF"/>
+              </a:solidFill>
+            </a:ln>
+          </p:spPr>
+          <p:style>
+            <a:lnRef idx="2">
+              <a:schemeClr val="accent1">
+                <a:shade val="15000"/>
+              </a:schemeClr>
+            </a:lnRef>
+            <a:fillRef idx="1">
+              <a:schemeClr val="accent1"/>
+            </a:fillRef>
+            <a:effectRef idx="0">
+              <a:schemeClr val="accent1"/>
+            </a:effectRef>
+            <a:fontRef idx="minor">
+              <a:schemeClr val="lt1"/>
+            </a:fontRef>
+          </p:style>
+          <p:txBody>
+            <a:bodyPr wrap="square" rtlCol="0" anchor="ctr">
+              <a:noAutofit/>
+            </a:bodyPr>
+            <a:lstStyle/>
+            <a:p>
+              <a:pPr algn="ctr"/>
+              <a:endParaRPr lang="pt-BR" dirty="0"/>
+            </a:p>
+          </p:txBody>
+        </p:sp>
+        <p:sp>
+          <p:nvSpPr>
+            <p:cNvPr id="4" name="Retângulo 3">
+              <a:extLst>
+                <a:ext uri="{FF2B5EF4-FFF2-40B4-BE49-F238E27FC236}">
+                  <a16:creationId xmlns:a16="http://schemas.microsoft.com/office/drawing/2014/main" id="{F1D86AD2-1F73-1090-B310-198546681602}"/>
+                </a:ext>
+              </a:extLst>
+            </p:cNvPr>
+            <p:cNvSpPr/>
+            <p:nvPr/>
+          </p:nvSpPr>
+          <p:spPr>
+            <a:xfrm>
+              <a:off x="5297274" y="2880621"/>
+              <a:ext cx="605038" cy="584775"/>
+            </a:xfrm>
+            <a:prstGeom prst="rect">
+              <a:avLst/>
+            </a:prstGeom>
+            <a:noFill/>
+          </p:spPr>
+          <p:txBody>
+            <a:bodyPr wrap="none" lIns="91440" tIns="45720" rIns="91440" bIns="45720">
+              <a:spAutoFit/>
+            </a:bodyPr>
+            <a:lstStyle/>
+            <a:p>
+              <a:pPr algn="ctr"/>
+              <a:r>
+                <a:rPr lang="pt-BR" sz="3200" b="1" dirty="0">
+                  <a:ln w="6600">
+                    <a:noFill/>
+                    <a:prstDash val="solid"/>
+                  </a:ln>
+                  <a:solidFill>
+                    <a:srgbClr val="FFFFFF"/>
+                  </a:solidFill>
+                </a:rPr>
+                <a:t>PT</a:t>
+              </a:r>
+            </a:p>
+          </p:txBody>
+        </p:sp>
+        <p:sp>
+          <p:nvSpPr>
+            <p:cNvPr id="14" name="CaixaDeTexto 13">
+              <a:extLst>
+                <a:ext uri="{FF2B5EF4-FFF2-40B4-BE49-F238E27FC236}">
+                  <a16:creationId xmlns:a16="http://schemas.microsoft.com/office/drawing/2014/main" id="{5CCD1CC7-3ACA-4016-A7A7-25C4AE11CED3}"/>
+                </a:ext>
+              </a:extLst>
+            </p:cNvPr>
+            <p:cNvSpPr txBox="1"/>
+            <p:nvPr/>
+          </p:nvSpPr>
+          <p:spPr>
+            <a:xfrm>
+              <a:off x="2607074" y="2392335"/>
+              <a:ext cx="1765358" cy="646331"/>
+            </a:xfrm>
+            <a:prstGeom prst="rect">
+              <a:avLst/>
+            </a:prstGeom>
+            <a:noFill/>
+          </p:spPr>
+          <p:txBody>
+            <a:bodyPr wrap="square" rtlCol="0">
+              <a:spAutoFit/>
+            </a:bodyPr>
+            <a:lstStyle>
+              <a:defPPr>
+                <a:defRPr lang="pt-BR"/>
+              </a:defPPr>
+              <a:lvl1pPr algn="ctr">
+                <a:defRPr>
+                  <a:solidFill>
+                    <a:srgbClr val="FFFFFF"/>
+                  </a:solidFill>
+                  <a:latin typeface="GT America Ultra Light" panose="020B0604020202020204" charset="0"/>
+                </a:defRPr>
+              </a:lvl1pPr>
+            </a:lstStyle>
+            <a:p>
+              <a:r>
+                <a:rPr lang="pt-BR" dirty="0"/>
+                <a:t>Planejamento</a:t>
+              </a:r>
+            </a:p>
+            <a:p>
+              <a:r>
+                <a:rPr lang="pt-BR" dirty="0"/>
+                <a:t>Tributário</a:t>
+              </a:r>
+            </a:p>
+          </p:txBody>
+        </p:sp>
+      </p:grpSp>
+      <p:grpSp>
+        <p:nvGrpSpPr>
+          <p:cNvPr id="90" name="Agrupar 89">
+            <a:extLst>
+              <a:ext uri="{FF2B5EF4-FFF2-40B4-BE49-F238E27FC236}">
+                <a16:creationId xmlns:a16="http://schemas.microsoft.com/office/drawing/2014/main" id="{BA8291F9-DED3-E6CE-E07A-50E900124A37}"/>
+              </a:ext>
+            </a:extLst>
+          </p:cNvPr>
+          <p:cNvGrpSpPr/>
+          <p:nvPr/>
+        </p:nvGrpSpPr>
+        <p:grpSpPr>
+          <a:xfrm>
+            <a:off x="2242668" y="3042767"/>
+            <a:ext cx="3108825" cy="1621105"/>
+            <a:chOff x="2435708" y="3318364"/>
+            <a:chExt cx="3108825" cy="1621105"/>
+          </a:xfrm>
+        </p:grpSpPr>
+        <p:sp>
+          <p:nvSpPr>
+            <p:cNvPr id="76" name="Forma Livre: Forma 75">
+              <a:extLst>
+                <a:ext uri="{FF2B5EF4-FFF2-40B4-BE49-F238E27FC236}">
+                  <a16:creationId xmlns:a16="http://schemas.microsoft.com/office/drawing/2014/main" id="{FAB64FC3-00AC-29A9-6B8B-4DD71C0FC2BB}"/>
+                </a:ext>
+              </a:extLst>
+            </p:cNvPr>
+            <p:cNvSpPr/>
+            <p:nvPr/>
+          </p:nvSpPr>
+          <p:spPr>
+            <a:xfrm rot="3415428" flipH="1">
+              <a:off x="4012112" y="3407048"/>
+              <a:ext cx="1621105" cy="1443737"/>
+            </a:xfrm>
+            <a:custGeom>
+              <a:avLst/>
+              <a:gdLst>
+                <a:gd name="connsiteX0" fmla="*/ 1621105 w 1621105"/>
+                <a:gd name="connsiteY0" fmla="*/ 387911 h 1443737"/>
+                <a:gd name="connsiteX1" fmla="*/ 743205 w 1621105"/>
+                <a:gd name="connsiteY1" fmla="*/ 0 h 1443737"/>
+                <a:gd name="connsiteX2" fmla="*/ 0 w 1621105"/>
+                <a:gd name="connsiteY2" fmla="*/ 484049 h 1443737"/>
+                <a:gd name="connsiteX3" fmla="*/ 0 w 1621105"/>
+                <a:gd name="connsiteY3" fmla="*/ 1443737 h 1443737"/>
+              </a:gdLst>
+              <a:ahLst/>
+              <a:cxnLst>
+                <a:cxn ang="0">
+                  <a:pos x="connsiteX0" y="connsiteY0"/>
+                </a:cxn>
+                <a:cxn ang="0">
+                  <a:pos x="connsiteX1" y="connsiteY1"/>
+                </a:cxn>
+                <a:cxn ang="0">
+                  <a:pos x="connsiteX2" y="connsiteY2"/>
+                </a:cxn>
+                <a:cxn ang="0">
+                  <a:pos x="connsiteX3" y="connsiteY3"/>
+                </a:cxn>
+              </a:cxnLst>
+              <a:rect l="l" t="t" r="r" b="b"/>
+              <a:pathLst>
+                <a:path w="1621105" h="1443737">
+                  <a:moveTo>
+                    <a:pt x="1621105" y="387911"/>
+                  </a:moveTo>
+                  <a:lnTo>
+                    <a:pt x="743205" y="0"/>
+                  </a:lnTo>
+                  <a:lnTo>
+                    <a:pt x="0" y="484049"/>
+                  </a:lnTo>
+                  <a:lnTo>
+                    <a:pt x="0" y="1443737"/>
+                  </a:lnTo>
+                  <a:close/>
+                </a:path>
+              </a:pathLst>
+            </a:custGeom>
+            <a:solidFill>
+              <a:srgbClr val="374A5C">
+                <a:alpha val="30000"/>
+              </a:srgbClr>
+            </a:solidFill>
+            <a:ln>
+              <a:solidFill>
+                <a:srgbClr val="FFFFFF"/>
+              </a:solidFill>
+            </a:ln>
+          </p:spPr>
+          <p:style>
+            <a:lnRef idx="2">
+              <a:schemeClr val="accent1">
+                <a:shade val="15000"/>
+              </a:schemeClr>
+            </a:lnRef>
+            <a:fillRef idx="1">
+              <a:schemeClr val="accent1"/>
+            </a:fillRef>
+            <a:effectRef idx="0">
+              <a:schemeClr val="accent1"/>
+            </a:effectRef>
+            <a:fontRef idx="minor">
+              <a:schemeClr val="lt1"/>
+            </a:fontRef>
+          </p:style>
+          <p:txBody>
+            <a:bodyPr wrap="square" rtlCol="0" anchor="ctr">
+              <a:noAutofit/>
+            </a:bodyPr>
+            <a:lstStyle/>
+            <a:p>
+              <a:pPr algn="ctr"/>
+              <a:endParaRPr lang="pt-BR" dirty="0"/>
+            </a:p>
+          </p:txBody>
+        </p:sp>
+        <p:sp>
+          <p:nvSpPr>
+            <p:cNvPr id="5" name="Retângulo 4">
+              <a:extLst>
+                <a:ext uri="{FF2B5EF4-FFF2-40B4-BE49-F238E27FC236}">
+                  <a16:creationId xmlns:a16="http://schemas.microsoft.com/office/drawing/2014/main" id="{0677D1EF-DA31-6D2D-22F1-F8B52B877BF3}"/>
+                </a:ext>
+              </a:extLst>
+            </p:cNvPr>
+            <p:cNvSpPr/>
+            <p:nvPr/>
+          </p:nvSpPr>
+          <p:spPr>
+            <a:xfrm>
+              <a:off x="4692201" y="3956261"/>
+              <a:ext cx="623312" cy="584775"/>
+            </a:xfrm>
+            <a:prstGeom prst="rect">
+              <a:avLst/>
+            </a:prstGeom>
+            <a:noFill/>
+          </p:spPr>
+          <p:txBody>
+            <a:bodyPr wrap="none" lIns="91440" tIns="45720" rIns="91440" bIns="45720">
+              <a:spAutoFit/>
+            </a:bodyPr>
+            <a:lstStyle/>
+            <a:p>
+              <a:pPr algn="ctr"/>
+              <a:r>
+                <a:rPr lang="pt-BR" sz="3200" b="1" dirty="0">
+                  <a:ln w="6600">
+                    <a:noFill/>
+                    <a:prstDash val="solid"/>
+                  </a:ln>
+                  <a:solidFill>
+                    <a:srgbClr val="FFFFFF"/>
+                  </a:solidFill>
+                </a:rPr>
+                <a:t>PA</a:t>
+              </a:r>
+              <a:endParaRPr lang="pt-BR" sz="3200" b="1" cap="none" spc="0" dirty="0">
+                <a:ln w="6600">
+                  <a:noFill/>
+                  <a:prstDash val="solid"/>
+                </a:ln>
+                <a:solidFill>
+                  <a:srgbClr val="FFFFFF"/>
+                </a:solidFill>
+              </a:endParaRPr>
+            </a:p>
+          </p:txBody>
+        </p:sp>
+        <p:sp>
+          <p:nvSpPr>
+            <p:cNvPr id="15" name="CaixaDeTexto 14">
+              <a:extLst>
+                <a:ext uri="{FF2B5EF4-FFF2-40B4-BE49-F238E27FC236}">
+                  <a16:creationId xmlns:a16="http://schemas.microsoft.com/office/drawing/2014/main" id="{30B19AEF-4D58-79C0-CA00-631625F010A9}"/>
+                </a:ext>
+              </a:extLst>
+            </p:cNvPr>
+            <p:cNvSpPr txBox="1"/>
+            <p:nvPr/>
+          </p:nvSpPr>
+          <p:spPr>
+            <a:xfrm>
+              <a:off x="2435708" y="4026785"/>
+              <a:ext cx="2108089" cy="646331"/>
+            </a:xfrm>
+            <a:prstGeom prst="rect">
+              <a:avLst/>
+            </a:prstGeom>
+            <a:noFill/>
+          </p:spPr>
+          <p:txBody>
+            <a:bodyPr wrap="square" rtlCol="0">
+              <a:spAutoFit/>
+            </a:bodyPr>
+            <a:lstStyle/>
+            <a:p>
+              <a:pPr algn="ctr"/>
+              <a:r>
+                <a:rPr lang="pt-BR" dirty="0">
+                  <a:solidFill>
+                    <a:srgbClr val="FFFFFF"/>
+                  </a:solidFill>
+                  <a:latin typeface="GT America Ultra Light" panose="020B0604020202020204" charset="0"/>
+                </a:rPr>
+                <a:t>Planejamento</a:t>
+              </a:r>
+            </a:p>
+            <a:p>
+              <a:pPr algn="ctr"/>
+              <a:r>
+                <a:rPr lang="pt-BR" dirty="0">
+                  <a:solidFill>
+                    <a:srgbClr val="FFFFFF"/>
+                  </a:solidFill>
+                  <a:latin typeface="GT America Ultra Light" panose="020B0604020202020204" charset="0"/>
+                </a:rPr>
+                <a:t>de Aposentadoria</a:t>
+              </a:r>
+            </a:p>
+          </p:txBody>
+        </p:sp>
+      </p:grpSp>
+      <p:grpSp>
+        <p:nvGrpSpPr>
+          <p:cNvPr id="91" name="Agrupar 90">
+            <a:extLst>
+              <a:ext uri="{FF2B5EF4-FFF2-40B4-BE49-F238E27FC236}">
+                <a16:creationId xmlns:a16="http://schemas.microsoft.com/office/drawing/2014/main" id="{322D28C2-45FC-2FB2-36E3-947333E524F4}"/>
+              </a:ext>
+            </a:extLst>
+          </p:cNvPr>
+          <p:cNvGrpSpPr/>
+          <p:nvPr/>
+        </p:nvGrpSpPr>
+        <p:grpSpPr>
+          <a:xfrm>
+            <a:off x="2413727" y="4480513"/>
+            <a:ext cx="3704245" cy="1727622"/>
+            <a:chOff x="2606767" y="4756110"/>
+            <a:chExt cx="3704245" cy="1727622"/>
+          </a:xfrm>
+        </p:grpSpPr>
+        <p:sp>
+          <p:nvSpPr>
+            <p:cNvPr id="74" name="Forma Livre: Forma 73">
+              <a:extLst>
+                <a:ext uri="{FF2B5EF4-FFF2-40B4-BE49-F238E27FC236}">
+                  <a16:creationId xmlns:a16="http://schemas.microsoft.com/office/drawing/2014/main" id="{1C6110D3-5D4B-3FB0-4D68-C85936EE6945}"/>
+                </a:ext>
+              </a:extLst>
+            </p:cNvPr>
+            <p:cNvSpPr/>
+            <p:nvPr/>
+          </p:nvSpPr>
+          <p:spPr>
+            <a:xfrm rot="3415428" flipH="1">
+              <a:off x="4919782" y="4801023"/>
+              <a:ext cx="1436143" cy="1346317"/>
+            </a:xfrm>
+            <a:custGeom>
+              <a:avLst/>
+              <a:gdLst>
+                <a:gd name="connsiteX0" fmla="*/ 1436143 w 1436143"/>
+                <a:gd name="connsiteY0" fmla="*/ 386921 h 1346317"/>
+                <a:gd name="connsiteX1" fmla="*/ 775564 w 1436143"/>
+                <a:gd name="connsiteY1" fmla="*/ 0 h 1346317"/>
+                <a:gd name="connsiteX2" fmla="*/ 0 w 1436143"/>
+                <a:gd name="connsiteY2" fmla="*/ 505126 h 1346317"/>
+                <a:gd name="connsiteX3" fmla="*/ 1436143 w 1436143"/>
+                <a:gd name="connsiteY3" fmla="*/ 1346317 h 1346317"/>
+              </a:gdLst>
+              <a:ahLst/>
+              <a:cxnLst>
+                <a:cxn ang="0">
+                  <a:pos x="connsiteX0" y="connsiteY0"/>
+                </a:cxn>
+                <a:cxn ang="0">
+                  <a:pos x="connsiteX1" y="connsiteY1"/>
+                </a:cxn>
+                <a:cxn ang="0">
+                  <a:pos x="connsiteX2" y="connsiteY2"/>
+                </a:cxn>
+                <a:cxn ang="0">
+                  <a:pos x="connsiteX3" y="connsiteY3"/>
+                </a:cxn>
+              </a:cxnLst>
+              <a:rect l="l" t="t" r="r" b="b"/>
+              <a:pathLst>
+                <a:path w="1436143" h="1346317">
+                  <a:moveTo>
+                    <a:pt x="1436143" y="386921"/>
+                  </a:moveTo>
+                  <a:lnTo>
+                    <a:pt x="775564" y="0"/>
+                  </a:lnTo>
+                  <a:lnTo>
+                    <a:pt x="0" y="505126"/>
+                  </a:lnTo>
+                  <a:lnTo>
+                    <a:pt x="1436143" y="1346317"/>
+                  </a:lnTo>
+                  <a:close/>
+                </a:path>
+              </a:pathLst>
+            </a:custGeom>
+            <a:solidFill>
+              <a:srgbClr val="5A6876"/>
+            </a:solidFill>
+            <a:ln>
+              <a:solidFill>
+                <a:srgbClr val="FFFFFF"/>
+              </a:solidFill>
+            </a:ln>
+          </p:spPr>
+          <p:style>
+            <a:lnRef idx="2">
+              <a:schemeClr val="accent1">
+                <a:shade val="15000"/>
+              </a:schemeClr>
+            </a:lnRef>
+            <a:fillRef idx="1">
+              <a:schemeClr val="accent1"/>
+            </a:fillRef>
+            <a:effectRef idx="0">
+              <a:schemeClr val="accent1"/>
+            </a:effectRef>
+            <a:fontRef idx="minor">
+              <a:schemeClr val="lt1"/>
+            </a:fontRef>
+          </p:style>
+          <p:txBody>
+            <a:bodyPr wrap="square" rtlCol="0" anchor="ctr">
+              <a:noAutofit/>
+            </a:bodyPr>
+            <a:lstStyle/>
+            <a:p>
+              <a:pPr algn="ctr"/>
+              <a:endParaRPr lang="pt-BR" dirty="0"/>
+            </a:p>
+          </p:txBody>
+        </p:sp>
+        <p:sp>
+          <p:nvSpPr>
+            <p:cNvPr id="10" name="Retângulo 9">
+              <a:extLst>
+                <a:ext uri="{FF2B5EF4-FFF2-40B4-BE49-F238E27FC236}">
+                  <a16:creationId xmlns:a16="http://schemas.microsoft.com/office/drawing/2014/main" id="{26B57080-FA64-AA06-C2C2-693E0AE477D4}"/>
+                </a:ext>
+              </a:extLst>
+            </p:cNvPr>
+            <p:cNvSpPr/>
+            <p:nvPr/>
+          </p:nvSpPr>
+          <p:spPr>
+            <a:xfrm>
+              <a:off x="5301474" y="4932805"/>
+              <a:ext cx="596638" cy="584775"/>
+            </a:xfrm>
+            <a:prstGeom prst="rect">
+              <a:avLst/>
+            </a:prstGeom>
+            <a:noFill/>
+          </p:spPr>
+          <p:txBody>
+            <a:bodyPr wrap="none" lIns="91440" tIns="45720" rIns="91440" bIns="45720">
+              <a:spAutoFit/>
+            </a:bodyPr>
+            <a:lstStyle/>
+            <a:p>
+              <a:pPr algn="ctr"/>
+              <a:r>
+                <a:rPr lang="pt-BR" sz="3200" b="1" dirty="0">
+                  <a:ln w="6600">
+                    <a:noFill/>
+                    <a:prstDash val="solid"/>
+                  </a:ln>
+                  <a:solidFill>
+                    <a:schemeClr val="bg1">
+                      <a:lumMod val="10000"/>
+                    </a:schemeClr>
+                  </a:solidFill>
+                </a:rPr>
+                <a:t>PS</a:t>
+              </a:r>
+              <a:endParaRPr lang="pt-BR" sz="3200" b="1" cap="none" spc="0" dirty="0">
+                <a:ln w="6600">
+                  <a:noFill/>
+                  <a:prstDash val="solid"/>
+                </a:ln>
+                <a:solidFill>
+                  <a:schemeClr val="bg1">
+                    <a:lumMod val="10000"/>
+                  </a:schemeClr>
+                </a:solidFill>
+              </a:endParaRPr>
+            </a:p>
+          </p:txBody>
+        </p:sp>
+        <p:sp>
+          <p:nvSpPr>
+            <p:cNvPr id="16" name="CaixaDeTexto 15">
+              <a:extLst>
+                <a:ext uri="{FF2B5EF4-FFF2-40B4-BE49-F238E27FC236}">
+                  <a16:creationId xmlns:a16="http://schemas.microsoft.com/office/drawing/2014/main" id="{11D94236-264A-F978-E7B9-FF99A1EAACD9}"/>
+                </a:ext>
+              </a:extLst>
+            </p:cNvPr>
+            <p:cNvSpPr txBox="1"/>
+            <p:nvPr/>
+          </p:nvSpPr>
+          <p:spPr>
+            <a:xfrm>
+              <a:off x="2606767" y="5529625"/>
+              <a:ext cx="2866268" cy="954107"/>
+            </a:xfrm>
+            <a:prstGeom prst="rect">
+              <a:avLst/>
+            </a:prstGeom>
+            <a:noFill/>
+          </p:spPr>
+          <p:txBody>
+            <a:bodyPr wrap="square" rtlCol="0">
+              <a:spAutoFit/>
+            </a:bodyPr>
+            <a:lstStyle/>
+            <a:p>
+              <a:pPr algn="ctr"/>
+              <a:r>
+                <a:rPr lang="pt-BR" sz="2800" b="1" dirty="0">
+                  <a:solidFill>
+                    <a:schemeClr val="accent2">
+                      <a:lumMod val="90000"/>
+                    </a:schemeClr>
+                  </a:solidFill>
+                  <a:latin typeface="GT America Bold" panose="020B0604020202020204" charset="0"/>
+                </a:rPr>
+                <a:t>Planejamento</a:t>
+              </a:r>
+            </a:p>
+            <a:p>
+              <a:pPr algn="ctr"/>
+              <a:r>
+                <a:rPr lang="pt-BR" sz="2800" b="1" dirty="0">
+                  <a:solidFill>
+                    <a:schemeClr val="accent2">
+                      <a:lumMod val="90000"/>
+                    </a:schemeClr>
+                  </a:solidFill>
+                  <a:latin typeface="GT America Bold" panose="020B0604020202020204" charset="0"/>
+                </a:rPr>
+                <a:t>Sucessório</a:t>
+              </a:r>
+            </a:p>
+          </p:txBody>
+        </p:sp>
+      </p:grpSp>
+      <p:grpSp>
+        <p:nvGrpSpPr>
+          <p:cNvPr id="88" name="Agrupar 87">
+            <a:extLst>
+              <a:ext uri="{FF2B5EF4-FFF2-40B4-BE49-F238E27FC236}">
+                <a16:creationId xmlns:a16="http://schemas.microsoft.com/office/drawing/2014/main" id="{17A18E3A-3691-695A-ADF1-CE68B414E07D}"/>
+              </a:ext>
+            </a:extLst>
+          </p:cNvPr>
+          <p:cNvGrpSpPr/>
+          <p:nvPr/>
+        </p:nvGrpSpPr>
+        <p:grpSpPr>
+          <a:xfrm>
+            <a:off x="5872885" y="1995416"/>
+            <a:ext cx="3626491" cy="1436739"/>
+            <a:chOff x="6065925" y="2271013"/>
+            <a:chExt cx="3626491" cy="1436739"/>
+          </a:xfrm>
+        </p:grpSpPr>
+        <p:sp>
+          <p:nvSpPr>
+            <p:cNvPr id="68" name="Forma Livre: Forma 67">
+              <a:extLst>
+                <a:ext uri="{FF2B5EF4-FFF2-40B4-BE49-F238E27FC236}">
+                  <a16:creationId xmlns:a16="http://schemas.microsoft.com/office/drawing/2014/main" id="{715F51BC-8774-3BEB-6048-8201F42221FC}"/>
+                </a:ext>
+              </a:extLst>
+            </p:cNvPr>
+            <p:cNvSpPr/>
+            <p:nvPr/>
+          </p:nvSpPr>
+          <p:spPr>
+            <a:xfrm rot="3415428" flipH="1">
+              <a:off x="6022833" y="2314105"/>
+              <a:ext cx="1436739" cy="1350555"/>
+            </a:xfrm>
+            <a:custGeom>
+              <a:avLst/>
+              <a:gdLst>
+                <a:gd name="connsiteX0" fmla="*/ 1436739 w 1436739"/>
+                <a:gd name="connsiteY0" fmla="*/ 841540 h 1350555"/>
+                <a:gd name="connsiteX1" fmla="*/ 0 w 1436739"/>
+                <a:gd name="connsiteY1" fmla="*/ 0 h 1350555"/>
+                <a:gd name="connsiteX2" fmla="*/ 0 w 1436739"/>
+                <a:gd name="connsiteY2" fmla="*/ 966783 h 1350555"/>
+                <a:gd name="connsiteX3" fmla="*/ 655203 w 1436739"/>
+                <a:gd name="connsiteY3" fmla="*/ 1350555 h 1350555"/>
+              </a:gdLst>
+              <a:ahLst/>
+              <a:cxnLst>
+                <a:cxn ang="0">
+                  <a:pos x="connsiteX0" y="connsiteY0"/>
+                </a:cxn>
+                <a:cxn ang="0">
+                  <a:pos x="connsiteX1" y="connsiteY1"/>
+                </a:cxn>
+                <a:cxn ang="0">
+                  <a:pos x="connsiteX2" y="connsiteY2"/>
+                </a:cxn>
+                <a:cxn ang="0">
+                  <a:pos x="connsiteX3" y="connsiteY3"/>
+                </a:cxn>
+              </a:cxnLst>
+              <a:rect l="l" t="t" r="r" b="b"/>
+              <a:pathLst>
+                <a:path w="1436739" h="1350555">
+                  <a:moveTo>
+                    <a:pt x="1436739" y="841540"/>
+                  </a:moveTo>
+                  <a:lnTo>
+                    <a:pt x="0" y="0"/>
+                  </a:lnTo>
+                  <a:lnTo>
+                    <a:pt x="0" y="966783"/>
+                  </a:lnTo>
+                  <a:lnTo>
+                    <a:pt x="655203" y="1350555"/>
+                  </a:lnTo>
+                  <a:close/>
+                </a:path>
+              </a:pathLst>
+            </a:custGeom>
+            <a:solidFill>
+              <a:srgbClr val="7D6731">
+                <a:alpha val="30000"/>
+              </a:srgbClr>
+            </a:solidFill>
+            <a:ln>
+              <a:solidFill>
+                <a:srgbClr val="FFFFFF"/>
+              </a:solidFill>
+            </a:ln>
+          </p:spPr>
+          <p:style>
+            <a:lnRef idx="2">
+              <a:schemeClr val="accent1">
+                <a:shade val="15000"/>
+              </a:schemeClr>
+            </a:lnRef>
+            <a:fillRef idx="1">
+              <a:schemeClr val="accent1"/>
+            </a:fillRef>
+            <a:effectRef idx="0">
+              <a:schemeClr val="accent1"/>
+            </a:effectRef>
+            <a:fontRef idx="minor">
+              <a:schemeClr val="lt1"/>
+            </a:fontRef>
+          </p:style>
+          <p:txBody>
+            <a:bodyPr wrap="square" rtlCol="0" anchor="ctr">
+              <a:noAutofit/>
+            </a:bodyPr>
+            <a:lstStyle/>
+            <a:p>
+              <a:pPr algn="ctr"/>
+              <a:endParaRPr lang="pt-BR"/>
+            </a:p>
+          </p:txBody>
+        </p:sp>
+        <p:sp>
+          <p:nvSpPr>
+            <p:cNvPr id="3" name="Retângulo 2">
+              <a:extLst>
+                <a:ext uri="{FF2B5EF4-FFF2-40B4-BE49-F238E27FC236}">
+                  <a16:creationId xmlns:a16="http://schemas.microsoft.com/office/drawing/2014/main" id="{F9518933-CF7D-6442-E796-65214449B609}"/>
+                </a:ext>
+              </a:extLst>
+            </p:cNvPr>
+            <p:cNvSpPr/>
+            <p:nvPr/>
+          </p:nvSpPr>
+          <p:spPr>
+            <a:xfrm>
+              <a:off x="6428801" y="2880621"/>
+              <a:ext cx="635110" cy="584775"/>
+            </a:xfrm>
+            <a:prstGeom prst="rect">
+              <a:avLst/>
+            </a:prstGeom>
+            <a:noFill/>
+            <a:ln>
+              <a:noFill/>
+            </a:ln>
+          </p:spPr>
+          <p:txBody>
+            <a:bodyPr wrap="none" lIns="91440" tIns="45720" rIns="91440" bIns="45720">
+              <a:spAutoFit/>
+            </a:bodyPr>
+            <a:lstStyle/>
+            <a:p>
+              <a:pPr algn="ctr"/>
+              <a:r>
+                <a:rPr lang="pt-BR" sz="3200" b="1" dirty="0">
+                  <a:ln w="6600">
+                    <a:noFill/>
+                    <a:prstDash val="solid"/>
+                  </a:ln>
+                  <a:solidFill>
+                    <a:srgbClr val="FFFFFF"/>
+                  </a:solidFill>
+                </a:rPr>
+                <a:t>GF</a:t>
+              </a:r>
+            </a:p>
+          </p:txBody>
+        </p:sp>
+        <p:sp>
+          <p:nvSpPr>
+            <p:cNvPr id="18" name="CaixaDeTexto 17">
+              <a:extLst>
+                <a:ext uri="{FF2B5EF4-FFF2-40B4-BE49-F238E27FC236}">
+                  <a16:creationId xmlns:a16="http://schemas.microsoft.com/office/drawing/2014/main" id="{11FE6E42-06CB-632F-FB9B-03FE87717B0F}"/>
+                </a:ext>
+              </a:extLst>
+            </p:cNvPr>
+            <p:cNvSpPr txBox="1"/>
+            <p:nvPr/>
+          </p:nvSpPr>
+          <p:spPr>
+            <a:xfrm>
+              <a:off x="7927058" y="2392334"/>
+              <a:ext cx="1765358" cy="646331"/>
+            </a:xfrm>
+            <a:prstGeom prst="rect">
+              <a:avLst/>
+            </a:prstGeom>
+            <a:noFill/>
+          </p:spPr>
+          <p:txBody>
+            <a:bodyPr wrap="square" rtlCol="0">
+              <a:spAutoFit/>
+            </a:bodyPr>
+            <a:lstStyle>
+              <a:defPPr>
+                <a:defRPr lang="pt-BR"/>
+              </a:defPPr>
+              <a:lvl1pPr algn="ctr">
+                <a:defRPr>
+                  <a:solidFill>
+                    <a:srgbClr val="FFFFFF"/>
+                  </a:solidFill>
+                  <a:latin typeface="GT America Ultra Light" panose="020B0604020202020204" charset="0"/>
+                </a:defRPr>
+              </a:lvl1pPr>
+            </a:lstStyle>
+            <a:p>
+              <a:r>
+                <a:rPr lang="pt-BR" dirty="0"/>
+                <a:t>Gestão</a:t>
+              </a:r>
+            </a:p>
+            <a:p>
+              <a:r>
+                <a:rPr lang="pt-BR" dirty="0"/>
+                <a:t>Financeira</a:t>
+              </a:r>
+            </a:p>
+          </p:txBody>
+        </p:sp>
+      </p:grpSp>
+      <p:grpSp>
+        <p:nvGrpSpPr>
+          <p:cNvPr id="97" name="Agrupar 96">
+            <a:extLst>
+              <a:ext uri="{FF2B5EF4-FFF2-40B4-BE49-F238E27FC236}">
+                <a16:creationId xmlns:a16="http://schemas.microsoft.com/office/drawing/2014/main" id="{8F5D52CE-0DDA-1EC2-DAEC-23F156AA9AC4}"/>
+              </a:ext>
+            </a:extLst>
+          </p:cNvPr>
+          <p:cNvGrpSpPr/>
+          <p:nvPr/>
+        </p:nvGrpSpPr>
+        <p:grpSpPr>
+          <a:xfrm>
+            <a:off x="5726984" y="4522115"/>
+            <a:ext cx="3868228" cy="1686020"/>
+            <a:chOff x="5920024" y="4797712"/>
+            <a:chExt cx="3868228" cy="1686020"/>
+          </a:xfrm>
+        </p:grpSpPr>
+        <p:sp>
+          <p:nvSpPr>
+            <p:cNvPr id="72" name="Forma Livre: Forma 71">
+              <a:extLst>
+                <a:ext uri="{FF2B5EF4-FFF2-40B4-BE49-F238E27FC236}">
+                  <a16:creationId xmlns:a16="http://schemas.microsoft.com/office/drawing/2014/main" id="{85CA7182-BF89-2529-360B-3BC28896F356}"/>
+                </a:ext>
+              </a:extLst>
+            </p:cNvPr>
+            <p:cNvSpPr/>
+            <p:nvPr/>
+          </p:nvSpPr>
+          <p:spPr>
+            <a:xfrm rot="3415428" flipH="1">
+              <a:off x="6259106" y="4458630"/>
+              <a:ext cx="972414" cy="1650577"/>
+            </a:xfrm>
+            <a:custGeom>
+              <a:avLst/>
+              <a:gdLst>
+                <a:gd name="connsiteX0" fmla="*/ 887044 w 972414"/>
+                <a:gd name="connsiteY0" fmla="*/ 391952 h 1650577"/>
+                <a:gd name="connsiteX1" fmla="*/ 0 w 972414"/>
+                <a:gd name="connsiteY1" fmla="*/ 0 h 1650577"/>
+                <a:gd name="connsiteX2" fmla="*/ 188385 w 972414"/>
+                <a:gd name="connsiteY2" fmla="*/ 1650577 h 1650577"/>
+                <a:gd name="connsiteX3" fmla="*/ 972414 w 972414"/>
+                <a:gd name="connsiteY3" fmla="*/ 1139939 h 1650577"/>
+              </a:gdLst>
+              <a:ahLst/>
+              <a:cxnLst>
+                <a:cxn ang="0">
+                  <a:pos x="connsiteX0" y="connsiteY0"/>
+                </a:cxn>
+                <a:cxn ang="0">
+                  <a:pos x="connsiteX1" y="connsiteY1"/>
+                </a:cxn>
+                <a:cxn ang="0">
+                  <a:pos x="connsiteX2" y="connsiteY2"/>
+                </a:cxn>
+                <a:cxn ang="0">
+                  <a:pos x="connsiteX3" y="connsiteY3"/>
+                </a:cxn>
+              </a:cxnLst>
+              <a:rect l="l" t="t" r="r" b="b"/>
+              <a:pathLst>
+                <a:path w="972414" h="1650577">
+                  <a:moveTo>
+                    <a:pt x="887044" y="391952"/>
+                  </a:moveTo>
+                  <a:lnTo>
+                    <a:pt x="0" y="0"/>
+                  </a:lnTo>
+                  <a:lnTo>
+                    <a:pt x="188385" y="1650577"/>
+                  </a:lnTo>
+                  <a:lnTo>
+                    <a:pt x="972414" y="1139939"/>
+                  </a:lnTo>
+                  <a:close/>
+                </a:path>
+              </a:pathLst>
+            </a:custGeom>
+            <a:solidFill>
+              <a:srgbClr val="D0AD74"/>
+            </a:solidFill>
+            <a:ln>
+              <a:solidFill>
+                <a:srgbClr val="FFFFFF"/>
+              </a:solidFill>
+            </a:ln>
+          </p:spPr>
+          <p:style>
+            <a:lnRef idx="2">
+              <a:schemeClr val="accent1">
+                <a:shade val="15000"/>
+              </a:schemeClr>
+            </a:lnRef>
+            <a:fillRef idx="1">
+              <a:schemeClr val="accent1"/>
+            </a:fillRef>
+            <a:effectRef idx="0">
+              <a:schemeClr val="accent1"/>
+            </a:effectRef>
+            <a:fontRef idx="minor">
+              <a:schemeClr val="lt1"/>
+            </a:fontRef>
+          </p:style>
+          <p:txBody>
+            <a:bodyPr wrap="square" rtlCol="0" anchor="ctr">
+              <a:noAutofit/>
+            </a:bodyPr>
+            <a:lstStyle/>
+            <a:p>
+              <a:pPr algn="ctr"/>
+              <a:endParaRPr lang="pt-BR"/>
+            </a:p>
+          </p:txBody>
+        </p:sp>
+        <p:sp>
+          <p:nvSpPr>
+            <p:cNvPr id="11" name="Retângulo 10">
+              <a:extLst>
+                <a:ext uri="{FF2B5EF4-FFF2-40B4-BE49-F238E27FC236}">
+                  <a16:creationId xmlns:a16="http://schemas.microsoft.com/office/drawing/2014/main" id="{F1833343-B0C3-AF5F-8402-79D320740014}"/>
+                </a:ext>
+              </a:extLst>
+            </p:cNvPr>
+            <p:cNvSpPr/>
+            <p:nvPr/>
+          </p:nvSpPr>
+          <p:spPr>
+            <a:xfrm>
+              <a:off x="6407962" y="4932805"/>
+              <a:ext cx="676788" cy="584775"/>
+            </a:xfrm>
+            <a:prstGeom prst="rect">
+              <a:avLst/>
+            </a:prstGeom>
+            <a:noFill/>
+          </p:spPr>
+          <p:txBody>
+            <a:bodyPr wrap="none" lIns="91440" tIns="45720" rIns="91440" bIns="45720">
+              <a:spAutoFit/>
+            </a:bodyPr>
+            <a:lstStyle/>
+            <a:p>
+              <a:pPr algn="ctr"/>
+              <a:r>
+                <a:rPr lang="pt-BR" sz="3200" b="1" cap="none" spc="0" dirty="0">
+                  <a:ln w="6600">
+                    <a:noFill/>
+                    <a:prstDash val="solid"/>
+                  </a:ln>
+                  <a:solidFill>
+                    <a:schemeClr val="bg1">
+                      <a:lumMod val="10000"/>
+                    </a:schemeClr>
+                  </a:solidFill>
+                </a:rPr>
+                <a:t>GR</a:t>
+              </a:r>
+            </a:p>
+          </p:txBody>
+        </p:sp>
+        <p:sp>
+          <p:nvSpPr>
+            <p:cNvPr id="20" name="CaixaDeTexto 19">
+              <a:hlinkClick r:id="rId4" action="ppaction://hlinksldjump"/>
+              <a:extLst>
+                <a:ext uri="{FF2B5EF4-FFF2-40B4-BE49-F238E27FC236}">
+                  <a16:creationId xmlns:a16="http://schemas.microsoft.com/office/drawing/2014/main" id="{9AA7BB67-46A0-DEB0-9D6F-7739356CE5FD}"/>
+                </a:ext>
+              </a:extLst>
+            </p:cNvPr>
+            <p:cNvSpPr txBox="1"/>
+            <p:nvPr/>
+          </p:nvSpPr>
+          <p:spPr>
+            <a:xfrm>
+              <a:off x="6551001" y="5529625"/>
+              <a:ext cx="3237251" cy="954107"/>
+            </a:xfrm>
+            <a:prstGeom prst="rect">
+              <a:avLst/>
+            </a:prstGeom>
+            <a:noFill/>
+          </p:spPr>
+          <p:txBody>
+            <a:bodyPr wrap="square" rtlCol="0">
+              <a:spAutoFit/>
+            </a:bodyPr>
+            <a:lstStyle/>
+            <a:p>
+              <a:pPr algn="ctr"/>
+              <a:r>
+                <a:rPr lang="pt-BR" sz="2800" b="1" dirty="0">
+                  <a:solidFill>
+                    <a:srgbClr val="FFC971"/>
+                  </a:solidFill>
+                  <a:latin typeface="GT America Bold" panose="020B0604020202020204" charset="0"/>
+                </a:rPr>
+                <a:t>Gestão de</a:t>
+              </a:r>
+            </a:p>
+            <a:p>
+              <a:pPr algn="ctr"/>
+              <a:r>
+                <a:rPr lang="pt-BR" sz="2800" b="1" dirty="0">
+                  <a:solidFill>
+                    <a:srgbClr val="FFC971"/>
+                  </a:solidFill>
+                  <a:latin typeface="GT America Bold" panose="020B0604020202020204" charset="0"/>
+                </a:rPr>
+                <a:t>Riscos</a:t>
+              </a:r>
+            </a:p>
+          </p:txBody>
+        </p:sp>
+      </p:grpSp>
+      <p:grpSp>
+        <p:nvGrpSpPr>
+          <p:cNvPr id="124" name="Agrupar 123">
+            <a:extLst>
+              <a:ext uri="{FF2B5EF4-FFF2-40B4-BE49-F238E27FC236}">
+                <a16:creationId xmlns:a16="http://schemas.microsoft.com/office/drawing/2014/main" id="{2077CCA5-5BFE-E04F-5637-EA8518A3D9FD}"/>
+              </a:ext>
+            </a:extLst>
+          </p:cNvPr>
+          <p:cNvGrpSpPr/>
+          <p:nvPr/>
+        </p:nvGrpSpPr>
+        <p:grpSpPr>
+          <a:xfrm>
+            <a:off x="5315137" y="3173037"/>
+            <a:ext cx="4292271" cy="1700068"/>
+            <a:chOff x="5508177" y="3448634"/>
+            <a:chExt cx="4292271" cy="1700068"/>
+          </a:xfrm>
+        </p:grpSpPr>
+        <p:sp>
+          <p:nvSpPr>
+            <p:cNvPr id="67" name="Hexágono 66">
+              <a:extLst>
+                <a:ext uri="{FF2B5EF4-FFF2-40B4-BE49-F238E27FC236}">
+                  <a16:creationId xmlns:a16="http://schemas.microsoft.com/office/drawing/2014/main" id="{5C40D2DF-3C11-DA06-A3B7-A149A24D37C6}"/>
+                </a:ext>
+              </a:extLst>
+            </p:cNvPr>
+            <p:cNvSpPr/>
+            <p:nvPr/>
+          </p:nvSpPr>
+          <p:spPr>
+            <a:xfrm rot="16200000">
+              <a:off x="5400177" y="3556634"/>
+              <a:ext cx="1566000" cy="1350000"/>
+            </a:xfrm>
+            <a:prstGeom prst="hexagon">
+              <a:avLst/>
+            </a:prstGeom>
+            <a:solidFill>
+              <a:schemeClr val="tx2"/>
+            </a:solidFill>
+            <a:ln>
+              <a:solidFill>
+                <a:srgbClr val="FFFFFF"/>
+              </a:solidFill>
+            </a:ln>
+          </p:spPr>
+          <p:style>
+            <a:lnRef idx="2">
+              <a:schemeClr val="accent1">
+                <a:shade val="15000"/>
+              </a:schemeClr>
+            </a:lnRef>
+            <a:fillRef idx="1">
+              <a:schemeClr val="accent1"/>
+            </a:fillRef>
+            <a:effectRef idx="0">
+              <a:schemeClr val="accent1"/>
+            </a:effectRef>
+            <a:fontRef idx="minor">
+              <a:schemeClr val="lt1"/>
+            </a:fontRef>
+          </p:style>
+          <p:txBody>
+            <a:bodyPr rtlCol="0" anchor="ctr"/>
+            <a:lstStyle/>
+            <a:p>
+              <a:pPr algn="ctr"/>
+              <a:endParaRPr lang="pt-BR"/>
+            </a:p>
+          </p:txBody>
+        </p:sp>
+        <p:sp>
+          <p:nvSpPr>
+            <p:cNvPr id="70" name="Forma Livre: Forma 69">
+              <a:extLst>
+                <a:ext uri="{FF2B5EF4-FFF2-40B4-BE49-F238E27FC236}">
+                  <a16:creationId xmlns:a16="http://schemas.microsoft.com/office/drawing/2014/main" id="{255FAAC2-8764-1962-7CCB-14DBD5D1F8D0}"/>
+                </a:ext>
+              </a:extLst>
+            </p:cNvPr>
+            <p:cNvSpPr/>
+            <p:nvPr/>
+          </p:nvSpPr>
+          <p:spPr>
+            <a:xfrm rot="3415428" flipH="1">
+              <a:off x="6737703" y="3620848"/>
+              <a:ext cx="1614921" cy="1440788"/>
+            </a:xfrm>
+            <a:custGeom>
+              <a:avLst/>
+              <a:gdLst>
+                <a:gd name="connsiteX0" fmla="*/ 1614921 w 1614921"/>
+                <a:gd name="connsiteY0" fmla="*/ 0 h 1440788"/>
+                <a:gd name="connsiteX1" fmla="*/ 0 w 1614921"/>
+                <a:gd name="connsiteY1" fmla="*/ 1051799 h 1440788"/>
+                <a:gd name="connsiteX2" fmla="*/ 880339 w 1614921"/>
+                <a:gd name="connsiteY2" fmla="*/ 1440788 h 1440788"/>
+                <a:gd name="connsiteX3" fmla="*/ 1614921 w 1614921"/>
+                <a:gd name="connsiteY3" fmla="*/ 962355 h 1440788"/>
+              </a:gdLst>
+              <a:ahLst/>
+              <a:cxnLst>
+                <a:cxn ang="0">
+                  <a:pos x="connsiteX0" y="connsiteY0"/>
+                </a:cxn>
+                <a:cxn ang="0">
+                  <a:pos x="connsiteX1" y="connsiteY1"/>
+                </a:cxn>
+                <a:cxn ang="0">
+                  <a:pos x="connsiteX2" y="connsiteY2"/>
+                </a:cxn>
+                <a:cxn ang="0">
+                  <a:pos x="connsiteX3" y="connsiteY3"/>
+                </a:cxn>
+              </a:cxnLst>
+              <a:rect l="l" t="t" r="r" b="b"/>
+              <a:pathLst>
+                <a:path w="1614921" h="1440788">
+                  <a:moveTo>
+                    <a:pt x="1614921" y="0"/>
+                  </a:moveTo>
+                  <a:lnTo>
+                    <a:pt x="0" y="1051799"/>
+                  </a:lnTo>
+                  <a:lnTo>
+                    <a:pt x="880339" y="1440788"/>
+                  </a:lnTo>
+                  <a:lnTo>
+                    <a:pt x="1614921" y="962355"/>
+                  </a:lnTo>
+                  <a:close/>
+                </a:path>
+              </a:pathLst>
+            </a:custGeom>
+            <a:solidFill>
+              <a:srgbClr val="A58745">
+                <a:alpha val="30000"/>
+              </a:srgbClr>
+            </a:solidFill>
+            <a:ln>
+              <a:solidFill>
+                <a:srgbClr val="FFFFFF"/>
+              </a:solidFill>
+            </a:ln>
+          </p:spPr>
+          <p:style>
+            <a:lnRef idx="2">
+              <a:schemeClr val="accent1">
+                <a:shade val="15000"/>
+              </a:schemeClr>
+            </a:lnRef>
+            <a:fillRef idx="1">
+              <a:schemeClr val="accent1"/>
+            </a:fillRef>
+            <a:effectRef idx="0">
+              <a:schemeClr val="accent1"/>
+            </a:effectRef>
+            <a:fontRef idx="minor">
+              <a:schemeClr val="lt1"/>
+            </a:fontRef>
+          </p:style>
+          <p:txBody>
+            <a:bodyPr wrap="square" rtlCol="0" anchor="ctr">
+              <a:noAutofit/>
+            </a:bodyPr>
+            <a:lstStyle/>
+            <a:p>
+              <a:pPr algn="ctr"/>
+              <a:endParaRPr lang="pt-BR"/>
+            </a:p>
+          </p:txBody>
+        </p:sp>
+        <p:pic>
+          <p:nvPicPr>
+            <p:cNvPr id="8" name="Imagem 7" descr="Uma imagem contendo faca&#10;&#10;Descrição gerada automaticamente">
+              <a:extLst>
+                <a:ext uri="{FF2B5EF4-FFF2-40B4-BE49-F238E27FC236}">
+                  <a16:creationId xmlns:a16="http://schemas.microsoft.com/office/drawing/2014/main" id="{CE0BF025-DE05-B4E0-9E99-B46BBA81C42F}"/>
+                </a:ext>
+              </a:extLst>
+            </p:cNvPr>
+            <p:cNvPicPr>
+              <a:picLocks noChangeAspect="1"/>
+            </p:cNvPicPr>
+            <p:nvPr/>
+          </p:nvPicPr>
+          <p:blipFill>
+            <a:blip r:embed="rId5">
+              <a:extLst>
+                <a:ext uri="{28A0092B-C50C-407E-A947-70E740481C1C}">
+                  <a14:useLocalDpi xmlns:a14="http://schemas.microsoft.com/office/drawing/2010/main" val="0"/>
+                </a:ext>
+              </a:extLst>
+            </a:blip>
+            <a:stretch>
+              <a:fillRect/>
+            </a:stretch>
+          </p:blipFill>
+          <p:spPr>
+            <a:xfrm>
+              <a:off x="5742670" y="4004658"/>
+              <a:ext cx="808331" cy="322201"/>
+            </a:xfrm>
+            <a:prstGeom prst="rect">
+              <a:avLst/>
+            </a:prstGeom>
+          </p:spPr>
+        </p:pic>
+        <p:sp>
+          <p:nvSpPr>
+            <p:cNvPr id="19" name="CaixaDeTexto 18">
+              <a:extLst>
+                <a:ext uri="{FF2B5EF4-FFF2-40B4-BE49-F238E27FC236}">
+                  <a16:creationId xmlns:a16="http://schemas.microsoft.com/office/drawing/2014/main" id="{B3E04DD6-E256-B062-D5E9-1F0927CAC118}"/>
+                </a:ext>
+              </a:extLst>
+            </p:cNvPr>
+            <p:cNvSpPr txBox="1"/>
+            <p:nvPr/>
+          </p:nvSpPr>
+          <p:spPr>
+            <a:xfrm>
+              <a:off x="8035090" y="3975442"/>
+              <a:ext cx="1765358" cy="646331"/>
+            </a:xfrm>
+            <a:prstGeom prst="rect">
+              <a:avLst/>
+            </a:prstGeom>
+            <a:noFill/>
+          </p:spPr>
+          <p:txBody>
+            <a:bodyPr wrap="square" rtlCol="0">
+              <a:spAutoFit/>
+            </a:bodyPr>
+            <a:lstStyle>
+              <a:defPPr>
+                <a:defRPr lang="pt-BR"/>
+              </a:defPPr>
+              <a:lvl1pPr algn="ctr">
+                <a:defRPr>
+                  <a:solidFill>
+                    <a:srgbClr val="FFFFFF"/>
+                  </a:solidFill>
+                  <a:latin typeface="GT America Ultra Light" panose="020B0604020202020204" charset="0"/>
+                </a:defRPr>
+              </a:lvl1pPr>
+            </a:lstStyle>
+            <a:p>
+              <a:r>
+                <a:rPr lang="pt-BR" dirty="0"/>
+                <a:t>Gestão</a:t>
+              </a:r>
+            </a:p>
+            <a:p>
+              <a:r>
+                <a:rPr lang="pt-BR" dirty="0"/>
+                <a:t>De Ativos</a:t>
+              </a:r>
+            </a:p>
+          </p:txBody>
+        </p:sp>
+        <p:sp>
+          <p:nvSpPr>
+            <p:cNvPr id="13" name="Retângulo 12">
+              <a:extLst>
+                <a:ext uri="{FF2B5EF4-FFF2-40B4-BE49-F238E27FC236}">
+                  <a16:creationId xmlns:a16="http://schemas.microsoft.com/office/drawing/2014/main" id="{F9DCE931-4183-337E-8DAD-10900421C5DC}"/>
+                </a:ext>
+              </a:extLst>
+            </p:cNvPr>
+            <p:cNvSpPr/>
+            <p:nvPr/>
+          </p:nvSpPr>
+          <p:spPr>
+            <a:xfrm>
+              <a:off x="6952740" y="3956261"/>
+              <a:ext cx="694421" cy="584775"/>
+            </a:xfrm>
+            <a:prstGeom prst="rect">
+              <a:avLst/>
+            </a:prstGeom>
+            <a:noFill/>
+          </p:spPr>
+          <p:txBody>
+            <a:bodyPr wrap="none" lIns="91440" tIns="45720" rIns="91440" bIns="45720">
+              <a:spAutoFit/>
+            </a:bodyPr>
+            <a:lstStyle/>
+            <a:p>
+              <a:pPr algn="ctr"/>
+              <a:r>
+                <a:rPr lang="pt-BR" sz="3200" b="1" dirty="0">
+                  <a:ln w="6600">
+                    <a:noFill/>
+                    <a:prstDash val="solid"/>
+                  </a:ln>
+                  <a:solidFill>
+                    <a:srgbClr val="FFFFFF"/>
+                  </a:solidFill>
+                </a:rPr>
+                <a:t>GA</a:t>
+              </a:r>
+            </a:p>
+          </p:txBody>
+        </p:sp>
+      </p:grpSp>
+      <p:cxnSp>
+        <p:nvCxnSpPr>
+          <p:cNvPr id="99" name="Conector Reto 3">
+            <a:extLst>
+              <a:ext uri="{FF2B5EF4-FFF2-40B4-BE49-F238E27FC236}">
+                <a16:creationId xmlns:a16="http://schemas.microsoft.com/office/drawing/2014/main" id="{3F162558-FB6A-2187-AEF6-DD3EAB3E41DD}"/>
+              </a:ext>
+            </a:extLst>
+          </p:cNvPr>
+          <p:cNvCxnSpPr>
+            <a:cxnSpLocks/>
+          </p:cNvCxnSpPr>
+          <p:nvPr/>
+        </p:nvCxnSpPr>
+        <p:spPr>
+          <a:xfrm>
+            <a:off x="1528462" y="2940828"/>
+            <a:ext cx="2694433" cy="0"/>
+          </a:xfrm>
+          <a:prstGeom prst="line">
+            <a:avLst/>
+          </a:prstGeom>
+          <a:ln w="12700">
+            <a:gradFill flip="none" rotWithShape="1">
+              <a:gsLst>
+                <a:gs pos="87000">
+                  <a:schemeClr val="accent1">
+                    <a:lumMod val="5000"/>
+                    <a:lumOff val="95000"/>
+                    <a:alpha val="0"/>
+                  </a:schemeClr>
+                </a:gs>
+                <a:gs pos="0">
+                  <a:srgbClr val="FFC971"/>
+                </a:gs>
+              </a:gsLst>
+              <a:lin ang="10800000" scaled="1"/>
+              <a:tileRect/>
+            </a:gradFill>
+          </a:ln>
+        </p:spPr>
+        <p:style>
+          <a:lnRef idx="1">
+            <a:schemeClr val="accent2"/>
+          </a:lnRef>
+          <a:fillRef idx="0">
+            <a:schemeClr val="accent2"/>
+          </a:fillRef>
+          <a:effectRef idx="0">
+            <a:schemeClr val="accent2"/>
+          </a:effectRef>
+          <a:fontRef idx="minor">
+            <a:schemeClr val="tx1"/>
+          </a:fontRef>
+        </p:style>
+      </p:cxnSp>
+      <p:cxnSp>
+        <p:nvCxnSpPr>
+          <p:cNvPr id="102" name="Conector Reto 3">
+            <a:extLst>
+              <a:ext uri="{FF2B5EF4-FFF2-40B4-BE49-F238E27FC236}">
+                <a16:creationId xmlns:a16="http://schemas.microsoft.com/office/drawing/2014/main" id="{ECC5C398-FC3D-CEF8-A4C7-ADF0A54C5CF1}"/>
+              </a:ext>
+            </a:extLst>
+          </p:cNvPr>
+          <p:cNvCxnSpPr>
+            <a:cxnSpLocks/>
+          </p:cNvCxnSpPr>
+          <p:nvPr/>
+        </p:nvCxnSpPr>
+        <p:spPr>
+          <a:xfrm>
+            <a:off x="1528462" y="5000912"/>
+            <a:ext cx="2694433" cy="0"/>
+          </a:xfrm>
+          <a:prstGeom prst="line">
+            <a:avLst/>
+          </a:prstGeom>
+          <a:ln w="12700">
+            <a:gradFill flip="none" rotWithShape="1">
+              <a:gsLst>
+                <a:gs pos="87000">
+                  <a:schemeClr val="accent1">
+                    <a:lumMod val="5000"/>
+                    <a:lumOff val="95000"/>
+                    <a:alpha val="0"/>
+                  </a:schemeClr>
+                </a:gs>
+                <a:gs pos="0">
+                  <a:srgbClr val="FFC971"/>
+                </a:gs>
+              </a:gsLst>
+              <a:lin ang="10800000" scaled="1"/>
+              <a:tileRect/>
+            </a:gradFill>
+          </a:ln>
+        </p:spPr>
+        <p:style>
+          <a:lnRef idx="1">
+            <a:schemeClr val="accent2"/>
+          </a:lnRef>
+          <a:fillRef idx="0">
+            <a:schemeClr val="accent2"/>
+          </a:fillRef>
+          <a:effectRef idx="0">
+            <a:schemeClr val="accent2"/>
+          </a:effectRef>
+          <a:fontRef idx="minor">
+            <a:schemeClr val="tx1"/>
+          </a:fontRef>
+        </p:style>
+      </p:cxnSp>
+      <p:cxnSp>
+        <p:nvCxnSpPr>
+          <p:cNvPr id="105" name="Conector Reto 3">
+            <a:extLst>
+              <a:ext uri="{FF2B5EF4-FFF2-40B4-BE49-F238E27FC236}">
+                <a16:creationId xmlns:a16="http://schemas.microsoft.com/office/drawing/2014/main" id="{B4E5C5A8-BD22-4672-937C-ACD728190344}"/>
+              </a:ext>
+            </a:extLst>
+          </p:cNvPr>
+          <p:cNvCxnSpPr>
+            <a:cxnSpLocks/>
+          </p:cNvCxnSpPr>
+          <p:nvPr/>
+        </p:nvCxnSpPr>
+        <p:spPr>
+          <a:xfrm flipH="1">
+            <a:off x="7803038" y="2940828"/>
+            <a:ext cx="2694433" cy="0"/>
+          </a:xfrm>
+          <a:prstGeom prst="line">
+            <a:avLst/>
+          </a:prstGeom>
+          <a:ln w="12700">
+            <a:gradFill flip="none" rotWithShape="1">
+              <a:gsLst>
+                <a:gs pos="87000">
+                  <a:schemeClr val="accent1">
+                    <a:lumMod val="5000"/>
+                    <a:lumOff val="95000"/>
+                    <a:alpha val="0"/>
+                  </a:schemeClr>
+                </a:gs>
+                <a:gs pos="0">
+                  <a:srgbClr val="FFC971"/>
+                </a:gs>
+              </a:gsLst>
+              <a:lin ang="10800000" scaled="1"/>
+              <a:tileRect/>
+            </a:gradFill>
+          </a:ln>
+        </p:spPr>
+        <p:style>
+          <a:lnRef idx="1">
+            <a:schemeClr val="accent2"/>
+          </a:lnRef>
+          <a:fillRef idx="0">
+            <a:schemeClr val="accent2"/>
+          </a:fillRef>
+          <a:effectRef idx="0">
+            <a:schemeClr val="accent2"/>
+          </a:effectRef>
+          <a:fontRef idx="minor">
+            <a:schemeClr val="tx1"/>
+          </a:fontRef>
+        </p:style>
+      </p:cxnSp>
+      <p:cxnSp>
+        <p:nvCxnSpPr>
+          <p:cNvPr id="106" name="Conector Reto 3">
+            <a:extLst>
+              <a:ext uri="{FF2B5EF4-FFF2-40B4-BE49-F238E27FC236}">
+                <a16:creationId xmlns:a16="http://schemas.microsoft.com/office/drawing/2014/main" id="{2EAFC397-ED49-744A-3F98-CEAA1BF82611}"/>
+              </a:ext>
+            </a:extLst>
+          </p:cNvPr>
+          <p:cNvCxnSpPr>
+            <a:cxnSpLocks/>
+          </p:cNvCxnSpPr>
+          <p:nvPr/>
+        </p:nvCxnSpPr>
+        <p:spPr>
+          <a:xfrm flipH="1">
+            <a:off x="7803038" y="5000912"/>
+            <a:ext cx="2694433" cy="0"/>
+          </a:xfrm>
+          <a:prstGeom prst="line">
+            <a:avLst/>
+          </a:prstGeom>
+          <a:ln w="12700">
+            <a:gradFill flip="none" rotWithShape="1">
+              <a:gsLst>
+                <a:gs pos="87000">
+                  <a:schemeClr val="accent1">
+                    <a:lumMod val="5000"/>
+                    <a:lumOff val="95000"/>
+                    <a:alpha val="0"/>
+                  </a:schemeClr>
+                </a:gs>
+                <a:gs pos="0">
+                  <a:srgbClr val="FFC971"/>
+                </a:gs>
+              </a:gsLst>
+              <a:lin ang="10800000" scaled="1"/>
+              <a:tileRect/>
+            </a:gradFill>
+          </a:ln>
+        </p:spPr>
+        <p:style>
+          <a:lnRef idx="1">
+            <a:schemeClr val="accent2"/>
+          </a:lnRef>
+          <a:fillRef idx="0">
+            <a:schemeClr val="accent2"/>
+          </a:fillRef>
+          <a:effectRef idx="0">
+            <a:schemeClr val="accent2"/>
+          </a:effectRef>
+          <a:fontRef idx="minor">
+            <a:schemeClr val="tx1"/>
+          </a:fontRef>
+        </p:style>
+      </p:cxnSp>
+      <p:sp>
+        <p:nvSpPr>
+          <p:cNvPr id="127" name="CaixaDeTexto 126">
+            <a:extLst>
+              <a:ext uri="{FF2B5EF4-FFF2-40B4-BE49-F238E27FC236}">
+                <a16:creationId xmlns:a16="http://schemas.microsoft.com/office/drawing/2014/main" id="{193DF82C-ED48-CD25-018D-04FE3CE37ACE}"/>
+              </a:ext>
+            </a:extLst>
+          </p:cNvPr>
+          <p:cNvSpPr txBox="1"/>
+          <p:nvPr/>
+        </p:nvSpPr>
+        <p:spPr>
+          <a:xfrm>
+            <a:off x="1607455" y="1227919"/>
+            <a:ext cx="3296093" cy="553998"/>
+          </a:xfrm>
+          <a:prstGeom prst="rect">
+            <a:avLst/>
+          </a:prstGeom>
+          <a:noFill/>
+        </p:spPr>
+        <p:txBody>
+          <a:bodyPr wrap="square" rtlCol="0">
+            <a:spAutoFit/>
+          </a:bodyPr>
+          <a:lstStyle/>
+          <a:p>
+            <a:r>
+              <a:rPr lang="pt-BR" sz="3000" dirty="0">
+                <a:solidFill>
+                  <a:srgbClr val="E5B46E"/>
+                </a:solidFill>
+                <a:latin typeface="GT America Ultra Light" panose="020B0604020202020204" charset="0"/>
+              </a:rPr>
+              <a:t>Atendimento 360</a:t>
+            </a:r>
+          </a:p>
+        </p:txBody>
+      </p:sp>
+      <p:pic>
+        <p:nvPicPr>
+          <p:cNvPr id="144" name="Imagem 143" descr="Uma imagem contendo faca&#10;&#10;Descrição gerada automaticamente">
+            <a:extLst>
+              <a:ext uri="{FF2B5EF4-FFF2-40B4-BE49-F238E27FC236}">
+                <a16:creationId xmlns:a16="http://schemas.microsoft.com/office/drawing/2014/main" id="{4FC28BAD-1AAF-22F7-F416-0F4D6C4A58D9}"/>
+              </a:ext>
+            </a:extLst>
+          </p:cNvPr>
+          <p:cNvPicPr>
+            <a:picLocks noChangeAspect="1"/>
+          </p:cNvPicPr>
+          <p:nvPr/>
+        </p:nvPicPr>
+        <p:blipFill>
+          <a:blip r:embed="rId5">
+            <a:extLst>
+              <a:ext uri="{28A0092B-C50C-407E-A947-70E740481C1C}">
+                <a14:useLocalDpi xmlns:a14="http://schemas.microsoft.com/office/drawing/2010/main" val="0"/>
+              </a:ext>
+            </a:extLst>
+          </a:blip>
+          <a:stretch>
+            <a:fillRect/>
+          </a:stretch>
+        </p:blipFill>
+        <p:spPr>
+          <a:xfrm>
+            <a:off x="979243" y="446345"/>
+            <a:ext cx="410366" cy="163572"/>
+          </a:xfrm>
+          <a:prstGeom prst="rect">
+            <a:avLst/>
+          </a:prstGeom>
+        </p:spPr>
+      </p:pic>
     </p:spTree>
     <p:extLst>
       <p:ext uri="{BB962C8B-B14F-4D97-AF65-F5344CB8AC3E}">
@@ -4916,6 +6837,267 @@
       </p:transition>
     </mc:Fallback>
   </mc:AlternateContent>
+  <p:timing>
+    <p:tnLst>
+      <p:par>
+        <p:cTn id="1" dur="indefinite" restart="never" nodeType="tmRoot">
+          <p:childTnLst>
+            <p:seq concurrent="1" nextAc="seek">
+              <p:cTn id="2" dur="indefinite" nodeType="mainSeq">
+                <p:childTnLst>
+                  <p:par>
+                    <p:cTn id="3" fill="hold">
+                      <p:stCondLst>
+                        <p:cond delay="indefinite"/>
+                      </p:stCondLst>
+                      <p:childTnLst>
+                        <p:par>
+                          <p:cTn id="4" fill="hold">
+                            <p:stCondLst>
+                              <p:cond delay="0"/>
+                            </p:stCondLst>
+                            <p:childTnLst>
+                              <p:par>
+                                <p:cTn id="5" presetID="22" presetClass="entr" presetSubtype="8" fill="hold" grpId="0" nodeType="clickEffect">
+                                  <p:stCondLst>
+                                    <p:cond delay="0"/>
+                                  </p:stCondLst>
+                                  <p:childTnLst>
+                                    <p:set>
+                                      <p:cBhvr>
+                                        <p:cTn id="6" dur="1" fill="hold">
+                                          <p:stCondLst>
+                                            <p:cond delay="0"/>
+                                          </p:stCondLst>
+                                        </p:cTn>
+                                        <p:tgtEl>
+                                          <p:spTgt spid="127"/>
+                                        </p:tgtEl>
+                                        <p:attrNameLst>
+                                          <p:attrName>style.visibility</p:attrName>
+                                        </p:attrNameLst>
+                                      </p:cBhvr>
+                                      <p:to>
+                                        <p:strVal val="visible"/>
+                                      </p:to>
+                                    </p:set>
+                                    <p:animEffect transition="in" filter="wipe(left)">
+                                      <p:cBhvr>
+                                        <p:cTn id="7" dur="1000"/>
+                                        <p:tgtEl>
+                                          <p:spTgt spid="127"/>
+                                        </p:tgtEl>
+                                      </p:cBhvr>
+                                    </p:animEffect>
+                                  </p:childTnLst>
+                                </p:cTn>
+                              </p:par>
+                              <p:par>
+                                <p:cTn id="8" presetID="10" presetClass="entr" presetSubtype="0" fill="hold" nodeType="withEffect">
+                                  <p:stCondLst>
+                                    <p:cond delay="0"/>
+                                  </p:stCondLst>
+                                  <p:childTnLst>
+                                    <p:set>
+                                      <p:cBhvr>
+                                        <p:cTn id="9" dur="1" fill="hold">
+                                          <p:stCondLst>
+                                            <p:cond delay="0"/>
+                                          </p:stCondLst>
+                                        </p:cTn>
+                                        <p:tgtEl>
+                                          <p:spTgt spid="88"/>
+                                        </p:tgtEl>
+                                        <p:attrNameLst>
+                                          <p:attrName>style.visibility</p:attrName>
+                                        </p:attrNameLst>
+                                      </p:cBhvr>
+                                      <p:to>
+                                        <p:strVal val="visible"/>
+                                      </p:to>
+                                    </p:set>
+                                    <p:animEffect transition="in" filter="fade">
+                                      <p:cBhvr>
+                                        <p:cTn id="10" dur="250"/>
+                                        <p:tgtEl>
+                                          <p:spTgt spid="88"/>
+                                        </p:tgtEl>
+                                      </p:cBhvr>
+                                    </p:animEffect>
+                                  </p:childTnLst>
+                                </p:cTn>
+                              </p:par>
+                              <p:par>
+                                <p:cTn id="11" presetID="10" presetClass="entr" presetSubtype="0" fill="hold" nodeType="withEffect">
+                                  <p:stCondLst>
+                                    <p:cond delay="250"/>
+                                  </p:stCondLst>
+                                  <p:childTnLst>
+                                    <p:set>
+                                      <p:cBhvr>
+                                        <p:cTn id="12" dur="1" fill="hold">
+                                          <p:stCondLst>
+                                            <p:cond delay="0"/>
+                                          </p:stCondLst>
+                                        </p:cTn>
+                                        <p:tgtEl>
+                                          <p:spTgt spid="89"/>
+                                        </p:tgtEl>
+                                        <p:attrNameLst>
+                                          <p:attrName>style.visibility</p:attrName>
+                                        </p:attrNameLst>
+                                      </p:cBhvr>
+                                      <p:to>
+                                        <p:strVal val="visible"/>
+                                      </p:to>
+                                    </p:set>
+                                    <p:animEffect transition="in" filter="fade">
+                                      <p:cBhvr>
+                                        <p:cTn id="13" dur="250"/>
+                                        <p:tgtEl>
+                                          <p:spTgt spid="89"/>
+                                        </p:tgtEl>
+                                      </p:cBhvr>
+                                    </p:animEffect>
+                                  </p:childTnLst>
+                                </p:cTn>
+                              </p:par>
+                              <p:par>
+                                <p:cTn id="14" presetID="10" presetClass="entr" presetSubtype="0" fill="hold" nodeType="withEffect">
+                                  <p:stCondLst>
+                                    <p:cond delay="500"/>
+                                  </p:stCondLst>
+                                  <p:childTnLst>
+                                    <p:set>
+                                      <p:cBhvr>
+                                        <p:cTn id="15" dur="1" fill="hold">
+                                          <p:stCondLst>
+                                            <p:cond delay="0"/>
+                                          </p:stCondLst>
+                                        </p:cTn>
+                                        <p:tgtEl>
+                                          <p:spTgt spid="90"/>
+                                        </p:tgtEl>
+                                        <p:attrNameLst>
+                                          <p:attrName>style.visibility</p:attrName>
+                                        </p:attrNameLst>
+                                      </p:cBhvr>
+                                      <p:to>
+                                        <p:strVal val="visible"/>
+                                      </p:to>
+                                    </p:set>
+                                    <p:animEffect transition="in" filter="fade">
+                                      <p:cBhvr>
+                                        <p:cTn id="16" dur="250"/>
+                                        <p:tgtEl>
+                                          <p:spTgt spid="90"/>
+                                        </p:tgtEl>
+                                      </p:cBhvr>
+                                    </p:animEffect>
+                                  </p:childTnLst>
+                                </p:cTn>
+                              </p:par>
+                              <p:par>
+                                <p:cTn id="17" presetID="10" presetClass="entr" presetSubtype="0" fill="hold" nodeType="withEffect">
+                                  <p:stCondLst>
+                                    <p:cond delay="750"/>
+                                  </p:stCondLst>
+                                  <p:childTnLst>
+                                    <p:set>
+                                      <p:cBhvr>
+                                        <p:cTn id="18" dur="1" fill="hold">
+                                          <p:stCondLst>
+                                            <p:cond delay="0"/>
+                                          </p:stCondLst>
+                                        </p:cTn>
+                                        <p:tgtEl>
+                                          <p:spTgt spid="91"/>
+                                        </p:tgtEl>
+                                        <p:attrNameLst>
+                                          <p:attrName>style.visibility</p:attrName>
+                                        </p:attrNameLst>
+                                      </p:cBhvr>
+                                      <p:to>
+                                        <p:strVal val="visible"/>
+                                      </p:to>
+                                    </p:set>
+                                    <p:animEffect transition="in" filter="fade">
+                                      <p:cBhvr>
+                                        <p:cTn id="19" dur="250"/>
+                                        <p:tgtEl>
+                                          <p:spTgt spid="91"/>
+                                        </p:tgtEl>
+                                      </p:cBhvr>
+                                    </p:animEffect>
+                                  </p:childTnLst>
+                                </p:cTn>
+                              </p:par>
+                              <p:par>
+                                <p:cTn id="20" presetID="10" presetClass="entr" presetSubtype="0" fill="hold" nodeType="withEffect">
+                                  <p:stCondLst>
+                                    <p:cond delay="1000"/>
+                                  </p:stCondLst>
+                                  <p:childTnLst>
+                                    <p:set>
+                                      <p:cBhvr>
+                                        <p:cTn id="21" dur="1" fill="hold">
+                                          <p:stCondLst>
+                                            <p:cond delay="0"/>
+                                          </p:stCondLst>
+                                        </p:cTn>
+                                        <p:tgtEl>
+                                          <p:spTgt spid="97"/>
+                                        </p:tgtEl>
+                                        <p:attrNameLst>
+                                          <p:attrName>style.visibility</p:attrName>
+                                        </p:attrNameLst>
+                                      </p:cBhvr>
+                                      <p:to>
+                                        <p:strVal val="visible"/>
+                                      </p:to>
+                                    </p:set>
+                                    <p:animEffect transition="in" filter="fade">
+                                      <p:cBhvr>
+                                        <p:cTn id="22" dur="250"/>
+                                        <p:tgtEl>
+                                          <p:spTgt spid="97"/>
+                                        </p:tgtEl>
+                                      </p:cBhvr>
+                                    </p:animEffect>
+                                  </p:childTnLst>
+                                </p:cTn>
+                              </p:par>
+                            </p:childTnLst>
+                          </p:cTn>
+                        </p:par>
+                      </p:childTnLst>
+                    </p:cTn>
+                  </p:par>
+                </p:childTnLst>
+              </p:cTn>
+              <p:prevCondLst>
+                <p:cond evt="onPrev" delay="0">
+                  <p:tgtEl>
+                    <p:sldTgt/>
+                  </p:tgtEl>
+                </p:cond>
+              </p:prevCondLst>
+              <p:nextCondLst>
+                <p:cond evt="onNext" delay="0">
+                  <p:tgtEl>
+                    <p:sldTgt/>
+                  </p:tgtEl>
+                </p:cond>
+              </p:nextCondLst>
+            </p:seq>
+          </p:childTnLst>
+        </p:cTn>
+      </p:par>
+    </p:tnLst>
+    <p:bldLst>
+      <p:bldP spid="127" grpId="0"/>
+    </p:bldLst>
+  </p:timing>
 </p:sld>
 </file>
 

</xml_diff>

<commit_message>
Preservar animacoes e setas do modelo
</commit_message>
<xml_diff>
--- a/public/assets/modelo-base.pptx
+++ b/public/assets/modelo-base.pptx
@@ -7234,6 +7234,1201 @@
           <a:chExt cx="0" cy="0"/>
         </a:xfrm>
       </p:grpSpPr>
+      <p:pic>
+        <p:nvPicPr>
+          <p:cNvPr id="12" name="Imagem 11" descr="Uma imagem contendo escuro, mesa, luz, aceso&#10;&#10;Descrição gerada automaticamente">
+            <a:extLst>
+              <a:ext uri="{FF2B5EF4-FFF2-40B4-BE49-F238E27FC236}">
+                <a16:creationId xmlns:a16="http://schemas.microsoft.com/office/drawing/2014/main" id="{78B3A849-DB7E-72F3-A529-019D535A2765}"/>
+              </a:ext>
+            </a:extLst>
+          </p:cNvPr>
+          <p:cNvPicPr>
+            <a:picLocks noChangeAspect="1"/>
+          </p:cNvPicPr>
+          <p:nvPr/>
+        </p:nvPicPr>
+        <p:blipFill rotWithShape="1">
+          <a:blip r:embed="rId3">
+            <a:extLst>
+              <a:ext uri="{28A0092B-C50C-407E-A947-70E740481C1C}">
+                <a14:useLocalDpi xmlns:a14="http://schemas.microsoft.com/office/drawing/2010/main" val="0"/>
+              </a:ext>
+            </a:extLst>
+          </a:blip>
+          <a:srcRect l="47191" t="1608" r="10113" b="12999"/>
+          <a:stretch>
+            <a:fillRect/>
+          </a:stretch>
+        </p:blipFill>
+        <p:spPr>
+          <a:xfrm>
+            <a:off x="0" y="0"/>
+            <a:ext cx="12192000" cy="6858000"/>
+          </a:xfrm>
+          <a:prstGeom prst="rect">
+            <a:avLst/>
+          </a:prstGeom>
+          <a:ln w="12700">
+            <a:noFill/>
+          </a:ln>
+        </p:spPr>
+      </p:pic>
+      <p:sp>
+        <p:nvSpPr>
+          <p:cNvPr id="2" name="CaixaDeTexto 1">
+            <a:extLst>
+              <a:ext uri="{FF2B5EF4-FFF2-40B4-BE49-F238E27FC236}">
+                <a16:creationId xmlns:a16="http://schemas.microsoft.com/office/drawing/2014/main" id="{52E6D4F7-ACD1-2781-158D-8EE3C78BDC4A}"/>
+              </a:ext>
+            </a:extLst>
+          </p:cNvPr>
+          <p:cNvSpPr txBox="1"/>
+          <p:nvPr/>
+        </p:nvSpPr>
+        <p:spPr>
+          <a:xfrm>
+            <a:off x="1588748" y="700909"/>
+            <a:ext cx="7863861" cy="605294"/>
+          </a:xfrm>
+          <a:prstGeom prst="rect">
+            <a:avLst/>
+          </a:prstGeom>
+          <a:noFill/>
+        </p:spPr>
+        <p:txBody>
+          <a:bodyPr wrap="square" rtlCol="0">
+            <a:spAutoFit/>
+          </a:bodyPr>
+          <a:lstStyle/>
+          <a:p>
+            <a:pPr>
+              <a:lnSpc>
+                <a:spcPts val="4000"/>
+              </a:lnSpc>
+              <a:tabLst>
+                <a:tab pos="2782888" algn="l"/>
+              </a:tabLst>
+            </a:pPr>
+            <a:r>
+              <a:rPr lang="da-DK" sz="4000" b="1" dirty="0">
+                <a:solidFill>
+                  <a:srgbClr val="FFFFFF"/>
+                </a:solidFill>
+                <a:latin typeface="GT America Bold" pitchFamily="2" charset="77"/>
+              </a:rPr>
+              <a:t>PLANEJAMENTO FINANCEIRO</a:t>
+            </a:r>
+            <a:endParaRPr lang="pt-BR" sz="3000" b="1" dirty="0">
+              <a:solidFill>
+                <a:srgbClr val="FFC971"/>
+              </a:solidFill>
+              <a:latin typeface="GT America Ultra Light" panose="00000300000000000000" pitchFamily="2" charset="0"/>
+            </a:endParaRPr>
+          </a:p>
+        </p:txBody>
+      </p:sp>
+      <p:sp>
+        <p:nvSpPr>
+          <p:cNvPr id="4" name="CaixaDeTexto 3">
+            <a:extLst>
+              <a:ext uri="{FF2B5EF4-FFF2-40B4-BE49-F238E27FC236}">
+                <a16:creationId xmlns:a16="http://schemas.microsoft.com/office/drawing/2014/main" id="{35B775C4-4212-F327-A6F2-47E87873DAD8}"/>
+              </a:ext>
+            </a:extLst>
+          </p:cNvPr>
+          <p:cNvSpPr txBox="1"/>
+          <p:nvPr/>
+        </p:nvSpPr>
+        <p:spPr>
+          <a:xfrm>
+            <a:off x="1609245" y="428519"/>
+            <a:ext cx="3495317" cy="263470"/>
+          </a:xfrm>
+          <a:prstGeom prst="rect">
+            <a:avLst/>
+          </a:prstGeom>
+          <a:noFill/>
+        </p:spPr>
+        <p:txBody>
+          <a:bodyPr wrap="square" rtlCol="0">
+            <a:spAutoFit/>
+          </a:bodyPr>
+          <a:lstStyle/>
+          <a:p>
+            <a:r>
+              <a:rPr lang="pt-BR" sz="1112" spc="600" dirty="0">
+                <a:solidFill>
+                  <a:srgbClr val="FFC971"/>
+                </a:solidFill>
+                <a:latin typeface="Lora" pitchFamily="2" charset="0"/>
+              </a:rPr>
+              <a:t>GESTÃO DE RISCOS</a:t>
+            </a:r>
+          </a:p>
+        </p:txBody>
+      </p:sp>
+      <p:sp>
+        <p:nvSpPr>
+          <p:cNvPr id="6" name="CaixaDeTexto 5">
+            <a:extLst>
+              <a:ext uri="{FF2B5EF4-FFF2-40B4-BE49-F238E27FC236}">
+                <a16:creationId xmlns:a16="http://schemas.microsoft.com/office/drawing/2014/main" id="{B7F4AE97-8AA8-91A4-2BE4-78D821F21BF9}"/>
+              </a:ext>
+            </a:extLst>
+          </p:cNvPr>
+          <p:cNvSpPr txBox="1"/>
+          <p:nvPr/>
+        </p:nvSpPr>
+        <p:spPr>
+          <a:xfrm>
+            <a:off x="1607455" y="1227919"/>
+            <a:ext cx="5695464" cy="523220"/>
+          </a:xfrm>
+          <a:prstGeom prst="rect">
+            <a:avLst/>
+          </a:prstGeom>
+          <a:noFill/>
+        </p:spPr>
+        <p:txBody>
+          <a:bodyPr wrap="square" rtlCol="0">
+            <a:spAutoFit/>
+          </a:bodyPr>
+          <a:lstStyle/>
+          <a:p>
+            <a:r>
+              <a:rPr lang="pt-BR" sz="2800" dirty="0">
+                <a:solidFill>
+                  <a:srgbClr val="FFC971"/>
+                </a:solidFill>
+                <a:latin typeface="GT America Ultra Light" panose="00000300000000000000" pitchFamily="2" charset="0"/>
+              </a:rPr>
+              <a:t>Estatísticas e Cenários</a:t>
+            </a:r>
+            <a:endParaRPr lang="pt-BR" sz="2800" dirty="0">
+              <a:solidFill>
+                <a:srgbClr val="E5B46E"/>
+              </a:solidFill>
+              <a:latin typeface="GT America Ultra Light" panose="020B0604020202020204" charset="0"/>
+            </a:endParaRPr>
+          </a:p>
+        </p:txBody>
+      </p:sp>
+      <p:cxnSp>
+        <p:nvCxnSpPr>
+          <p:cNvPr id="9" name="Conector Reto 3">
+            <a:extLst>
+              <a:ext uri="{FF2B5EF4-FFF2-40B4-BE49-F238E27FC236}">
+                <a16:creationId xmlns:a16="http://schemas.microsoft.com/office/drawing/2014/main" id="{0232E5B7-6052-5687-E9F3-FE7FC45BEE14}"/>
+              </a:ext>
+            </a:extLst>
+          </p:cNvPr>
+          <p:cNvCxnSpPr>
+            <a:cxnSpLocks/>
+          </p:cNvCxnSpPr>
+          <p:nvPr/>
+        </p:nvCxnSpPr>
+        <p:spPr>
+          <a:xfrm flipV="1">
+            <a:off x="1181374" y="579120"/>
+            <a:ext cx="0" cy="6456041"/>
+          </a:xfrm>
+          <a:prstGeom prst="line">
+            <a:avLst/>
+          </a:prstGeom>
+          <a:ln>
+            <a:gradFill>
+              <a:gsLst>
+                <a:gs pos="100000">
+                  <a:srgbClr val="FFC971">
+                    <a:alpha val="0"/>
+                  </a:srgbClr>
+                </a:gs>
+                <a:gs pos="0">
+                  <a:srgbClr val="FFC971"/>
+                </a:gs>
+              </a:gsLst>
+              <a:lin ang="5400000" scaled="1"/>
+            </a:gradFill>
+          </a:ln>
+        </p:spPr>
+        <p:style>
+          <a:lnRef idx="1">
+            <a:schemeClr val="accent2"/>
+          </a:lnRef>
+          <a:fillRef idx="0">
+            <a:schemeClr val="accent2"/>
+          </a:fillRef>
+          <a:effectRef idx="0">
+            <a:schemeClr val="accent2"/>
+          </a:effectRef>
+          <a:fontRef idx="minor">
+            <a:schemeClr val="tx1"/>
+          </a:fontRef>
+        </p:style>
+      </p:cxnSp>
+      <p:grpSp>
+        <p:nvGrpSpPr>
+          <p:cNvPr id="3" name="Agrupar 2">
+            <a:extLst>
+              <a:ext uri="{FF2B5EF4-FFF2-40B4-BE49-F238E27FC236}">
+                <a16:creationId xmlns:a16="http://schemas.microsoft.com/office/drawing/2014/main" id="{FA7DEC8B-795A-173A-5B7D-E8C894C46A11}"/>
+              </a:ext>
+            </a:extLst>
+          </p:cNvPr>
+          <p:cNvGrpSpPr/>
+          <p:nvPr/>
+        </p:nvGrpSpPr>
+        <p:grpSpPr>
+          <a:xfrm>
+            <a:off x="1551279" y="1830992"/>
+            <a:ext cx="10184836" cy="1872328"/>
+            <a:chOff x="1551279" y="1830992"/>
+            <a:chExt cx="10184836" cy="1872328"/>
+          </a:xfrm>
+        </p:grpSpPr>
+        <p:sp>
+          <p:nvSpPr>
+            <p:cNvPr id="19" name="Retângulo: Cantos Arredondados 18">
+              <a:extLst>
+                <a:ext uri="{FF2B5EF4-FFF2-40B4-BE49-F238E27FC236}">
+                  <a16:creationId xmlns:a16="http://schemas.microsoft.com/office/drawing/2014/main" id="{96C87568-36B0-513F-D7D0-923690A898DE}"/>
+                </a:ext>
+              </a:extLst>
+            </p:cNvPr>
+            <p:cNvSpPr/>
+            <p:nvPr/>
+          </p:nvSpPr>
+          <p:spPr>
+            <a:xfrm>
+              <a:off x="1551279" y="1830992"/>
+              <a:ext cx="10178143" cy="1847247"/>
+            </a:xfrm>
+            <a:prstGeom prst="roundRect">
+              <a:avLst/>
+            </a:prstGeom>
+            <a:solidFill>
+              <a:srgbClr val="FFC971">
+                <a:alpha val="20000"/>
+              </a:srgbClr>
+            </a:solidFill>
+          </p:spPr>
+          <p:style>
+            <a:lnRef idx="2">
+              <a:schemeClr val="accent1">
+                <a:shade val="15000"/>
+              </a:schemeClr>
+            </a:lnRef>
+            <a:fillRef idx="1">
+              <a:schemeClr val="accent1"/>
+            </a:fillRef>
+            <a:effectRef idx="0">
+              <a:schemeClr val="accent1"/>
+            </a:effectRef>
+            <a:fontRef idx="minor">
+              <a:schemeClr val="lt1"/>
+            </a:fontRef>
+          </p:style>
+          <p:txBody>
+            <a:bodyPr rtlCol="0" anchor="ctr"/>
+            <a:lstStyle/>
+            <a:p>
+              <a:pPr algn="ctr"/>
+              <a:endParaRPr lang="pt-BR"/>
+            </a:p>
+          </p:txBody>
+        </p:sp>
+        <p:sp>
+          <p:nvSpPr>
+            <p:cNvPr id="20" name="CaixaDeTexto 19">
+              <a:extLst>
+                <a:ext uri="{FF2B5EF4-FFF2-40B4-BE49-F238E27FC236}">
+                  <a16:creationId xmlns:a16="http://schemas.microsoft.com/office/drawing/2014/main" id="{BB573D92-E9E7-083D-563F-37B65E562946}"/>
+                </a:ext>
+              </a:extLst>
+            </p:cNvPr>
+            <p:cNvSpPr txBox="1"/>
+            <p:nvPr/>
+          </p:nvSpPr>
+          <p:spPr>
+            <a:xfrm>
+              <a:off x="1826636" y="2005683"/>
+              <a:ext cx="9717852" cy="1446550"/>
+            </a:xfrm>
+            <a:prstGeom prst="rect">
+              <a:avLst/>
+            </a:prstGeom>
+            <a:noFill/>
+          </p:spPr>
+          <p:txBody>
+            <a:bodyPr wrap="square" rtlCol="0">
+              <a:spAutoFit/>
+            </a:bodyPr>
+            <a:lstStyle/>
+            <a:p>
+              <a:pPr algn="ctr"/>
+              <a:r>
+                <a:rPr lang="pt-BR" sz="3200" b="1" u="sng" dirty="0">
+                  <a:solidFill>
+                    <a:srgbClr val="B89560"/>
+                  </a:solidFill>
+                  <a:latin typeface="GT America Bold" panose="020B0604020202020204" charset="0"/>
+                  <a:cs typeface="Calibri" panose="020F0502020204030204" pitchFamily="34" charset="0"/>
+                </a:rPr>
+                <a:t>R$ 3 BILHÕES DE REAIS</a:t>
+              </a:r>
+            </a:p>
+            <a:p>
+              <a:pPr algn="ctr"/>
+              <a:endParaRPr lang="pt-BR" sz="1600" b="1" u="sng" dirty="0">
+                <a:solidFill>
+                  <a:srgbClr val="FFFFFF"/>
+                </a:solidFill>
+                <a:latin typeface="GT America Bold" panose="020B0604020202020204" charset="0"/>
+                <a:cs typeface="Calibri" panose="020F0502020204030204" pitchFamily="34" charset="0"/>
+              </a:endParaRPr>
+            </a:p>
+            <a:p>
+              <a:pPr algn="ctr"/>
+              <a:r>
+                <a:rPr lang="pt-BR" sz="2000" dirty="0">
+                  <a:solidFill>
+                    <a:srgbClr val="FFFFFF"/>
+                  </a:solidFill>
+                  <a:latin typeface="GT America Ultra Light" panose="020B0604020202020204" charset="0"/>
+                  <a:cs typeface="Calibri" panose="020F0502020204030204" pitchFamily="34" charset="0"/>
+                </a:rPr>
+                <a:t>ENCONTRAM-SE JUDICIALMENTE BLOQUEADOS EM CONTAS NA XP, AGUARDANDO A CONCLUSÃO DOS PROCESSOS DE </a:t>
+              </a:r>
+              <a:r>
+                <a:rPr lang="pt-BR" sz="2000" b="1" dirty="0">
+                  <a:solidFill>
+                    <a:srgbClr val="FFFFFF"/>
+                  </a:solidFill>
+                  <a:latin typeface="GT America Bold" panose="020B0604020202020204" charset="0"/>
+                  <a:cs typeface="Calibri" panose="020F0502020204030204" pitchFamily="34" charset="0"/>
+                </a:rPr>
+                <a:t>INVENTÁRIOS.</a:t>
+              </a:r>
+            </a:p>
+          </p:txBody>
+        </p:sp>
+        <p:sp>
+          <p:nvSpPr>
+            <p:cNvPr id="23" name="Forma Livre: Forma 22">
+              <a:extLst>
+                <a:ext uri="{FF2B5EF4-FFF2-40B4-BE49-F238E27FC236}">
+                  <a16:creationId xmlns:a16="http://schemas.microsoft.com/office/drawing/2014/main" id="{6BD13D46-7AB9-3A44-65ED-2FC11510010B}"/>
+                </a:ext>
+              </a:extLst>
+            </p:cNvPr>
+            <p:cNvSpPr/>
+            <p:nvPr/>
+          </p:nvSpPr>
+          <p:spPr>
+            <a:xfrm>
+              <a:off x="1557972" y="3393400"/>
+              <a:ext cx="10178143" cy="309920"/>
+            </a:xfrm>
+            <a:custGeom>
+              <a:avLst/>
+              <a:gdLst>
+                <a:gd name="connsiteX0" fmla="*/ 0 w 10178143"/>
+                <a:gd name="connsiteY0" fmla="*/ 0 h 309920"/>
+                <a:gd name="connsiteX1" fmla="*/ 221340 w 10178143"/>
+                <a:gd name="connsiteY1" fmla="*/ 221340 h 309920"/>
+                <a:gd name="connsiteX2" fmla="*/ 9956803 w 10178143"/>
+                <a:gd name="connsiteY2" fmla="*/ 221340 h 309920"/>
+                <a:gd name="connsiteX3" fmla="*/ 10178143 w 10178143"/>
+                <a:gd name="connsiteY3" fmla="*/ 0 h 309920"/>
+                <a:gd name="connsiteX4" fmla="*/ 10178143 w 10178143"/>
+                <a:gd name="connsiteY4" fmla="*/ 88580 h 309920"/>
+                <a:gd name="connsiteX5" fmla="*/ 9956803 w 10178143"/>
+                <a:gd name="connsiteY5" fmla="*/ 309920 h 309920"/>
+                <a:gd name="connsiteX6" fmla="*/ 221340 w 10178143"/>
+                <a:gd name="connsiteY6" fmla="*/ 309920 h 309920"/>
+                <a:gd name="connsiteX7" fmla="*/ 0 w 10178143"/>
+                <a:gd name="connsiteY7" fmla="*/ 88580 h 309920"/>
+              </a:gdLst>
+              <a:ahLst/>
+              <a:cxnLst>
+                <a:cxn ang="0">
+                  <a:pos x="connsiteX0" y="connsiteY0"/>
+                </a:cxn>
+                <a:cxn ang="0">
+                  <a:pos x="connsiteX1" y="connsiteY1"/>
+                </a:cxn>
+                <a:cxn ang="0">
+                  <a:pos x="connsiteX2" y="connsiteY2"/>
+                </a:cxn>
+                <a:cxn ang="0">
+                  <a:pos x="connsiteX3" y="connsiteY3"/>
+                </a:cxn>
+                <a:cxn ang="0">
+                  <a:pos x="connsiteX4" y="connsiteY4"/>
+                </a:cxn>
+                <a:cxn ang="0">
+                  <a:pos x="connsiteX5" y="connsiteY5"/>
+                </a:cxn>
+                <a:cxn ang="0">
+                  <a:pos x="connsiteX6" y="connsiteY6"/>
+                </a:cxn>
+                <a:cxn ang="0">
+                  <a:pos x="connsiteX7" y="connsiteY7"/>
+                </a:cxn>
+              </a:cxnLst>
+              <a:rect l="l" t="t" r="r" b="b"/>
+              <a:pathLst>
+                <a:path w="10178143" h="309920">
+                  <a:moveTo>
+                    <a:pt x="0" y="0"/>
+                  </a:moveTo>
+                  <a:cubicBezTo>
+                    <a:pt x="0" y="122243"/>
+                    <a:pt x="99097" y="221340"/>
+                    <a:pt x="221340" y="221340"/>
+                  </a:cubicBezTo>
+                  <a:lnTo>
+                    <a:pt x="9956803" y="221340"/>
+                  </a:lnTo>
+                  <a:cubicBezTo>
+                    <a:pt x="10079046" y="221340"/>
+                    <a:pt x="10178143" y="122243"/>
+                    <a:pt x="10178143" y="0"/>
+                  </a:cubicBezTo>
+                  <a:lnTo>
+                    <a:pt x="10178143" y="88580"/>
+                  </a:lnTo>
+                  <a:cubicBezTo>
+                    <a:pt x="10178143" y="210823"/>
+                    <a:pt x="10079046" y="309920"/>
+                    <a:pt x="9956803" y="309920"/>
+                  </a:cubicBezTo>
+                  <a:lnTo>
+                    <a:pt x="221340" y="309920"/>
+                  </a:lnTo>
+                  <a:cubicBezTo>
+                    <a:pt x="99097" y="309920"/>
+                    <a:pt x="0" y="210823"/>
+                    <a:pt x="0" y="88580"/>
+                  </a:cubicBezTo>
+                  <a:close/>
+                </a:path>
+              </a:pathLst>
+            </a:custGeom>
+            <a:solidFill>
+              <a:srgbClr val="B89560"/>
+            </a:solidFill>
+          </p:spPr>
+          <p:style>
+            <a:lnRef idx="2">
+              <a:schemeClr val="accent1">
+                <a:shade val="15000"/>
+              </a:schemeClr>
+            </a:lnRef>
+            <a:fillRef idx="1">
+              <a:schemeClr val="accent1"/>
+            </a:fillRef>
+            <a:effectRef idx="0">
+              <a:schemeClr val="accent1"/>
+            </a:effectRef>
+            <a:fontRef idx="minor">
+              <a:schemeClr val="lt1"/>
+            </a:fontRef>
+          </p:style>
+          <p:txBody>
+            <a:bodyPr wrap="square" rtlCol="0" anchor="ctr">
+              <a:noAutofit/>
+            </a:bodyPr>
+            <a:lstStyle/>
+            <a:p>
+              <a:pPr algn="ctr"/>
+              <a:endParaRPr lang="pt-BR">
+                <a:solidFill>
+                  <a:srgbClr val="001137"/>
+                </a:solidFill>
+              </a:endParaRPr>
+            </a:p>
+          </p:txBody>
+        </p:sp>
+      </p:grpSp>
+      <p:pic>
+        <p:nvPicPr>
+          <p:cNvPr id="24" name="Imagem 23" descr="Uma imagem contendo faca&#10;&#10;Descrição gerada automaticamente">
+            <a:extLst>
+              <a:ext uri="{FF2B5EF4-FFF2-40B4-BE49-F238E27FC236}">
+                <a16:creationId xmlns:a16="http://schemas.microsoft.com/office/drawing/2014/main" id="{D5A494D2-0594-FB79-289B-A40F25B805CD}"/>
+              </a:ext>
+            </a:extLst>
+          </p:cNvPr>
+          <p:cNvPicPr>
+            <a:picLocks noChangeAspect="1"/>
+          </p:cNvPicPr>
+          <p:nvPr/>
+        </p:nvPicPr>
+        <p:blipFill>
+          <a:blip r:embed="rId4">
+            <a:extLst>
+              <a:ext uri="{28A0092B-C50C-407E-A947-70E740481C1C}">
+                <a14:useLocalDpi xmlns:a14="http://schemas.microsoft.com/office/drawing/2010/main" val="0"/>
+              </a:ext>
+            </a:extLst>
+          </a:blip>
+          <a:stretch>
+            <a:fillRect/>
+          </a:stretch>
+        </p:blipFill>
+        <p:spPr>
+          <a:xfrm>
+            <a:off x="979243" y="446345"/>
+            <a:ext cx="410366" cy="163572"/>
+          </a:xfrm>
+          <a:prstGeom prst="rect">
+            <a:avLst/>
+          </a:prstGeom>
+        </p:spPr>
+      </p:pic>
+      <p:grpSp>
+        <p:nvGrpSpPr>
+          <p:cNvPr id="5" name="Agrupar 4">
+            <a:extLst>
+              <a:ext uri="{FF2B5EF4-FFF2-40B4-BE49-F238E27FC236}">
+                <a16:creationId xmlns:a16="http://schemas.microsoft.com/office/drawing/2014/main" id="{6296DC5A-D7AF-0881-68AD-1A5B264F167C}"/>
+              </a:ext>
+            </a:extLst>
+          </p:cNvPr>
+          <p:cNvGrpSpPr/>
+          <p:nvPr/>
+        </p:nvGrpSpPr>
+        <p:grpSpPr>
+          <a:xfrm>
+            <a:off x="1551279" y="3975431"/>
+            <a:ext cx="2444628" cy="2337548"/>
+            <a:chOff x="1588748" y="3975765"/>
+            <a:chExt cx="3304356" cy="2337548"/>
+          </a:xfrm>
+        </p:grpSpPr>
+        <p:sp>
+          <p:nvSpPr>
+            <p:cNvPr id="25" name="Retângulo: Cantos Arredondados 24">
+              <a:extLst>
+                <a:ext uri="{FF2B5EF4-FFF2-40B4-BE49-F238E27FC236}">
+                  <a16:creationId xmlns:a16="http://schemas.microsoft.com/office/drawing/2014/main" id="{BDDE0B9A-6E6D-A5C7-63C5-F386EE58C550}"/>
+                </a:ext>
+              </a:extLst>
+            </p:cNvPr>
+            <p:cNvSpPr/>
+            <p:nvPr/>
+          </p:nvSpPr>
+          <p:spPr>
+            <a:xfrm>
+              <a:off x="1588748" y="3975765"/>
+              <a:ext cx="3304356" cy="2337548"/>
+            </a:xfrm>
+            <a:prstGeom prst="roundRect">
+              <a:avLst>
+                <a:gd name="adj" fmla="val 5801"/>
+              </a:avLst>
+            </a:prstGeom>
+            <a:solidFill>
+              <a:srgbClr val="FFFFFF">
+                <a:alpha val="20000"/>
+              </a:srgbClr>
+            </a:solidFill>
+          </p:spPr>
+          <p:style>
+            <a:lnRef idx="2">
+              <a:schemeClr val="accent1">
+                <a:shade val="15000"/>
+              </a:schemeClr>
+            </a:lnRef>
+            <a:fillRef idx="1">
+              <a:schemeClr val="accent1"/>
+            </a:fillRef>
+            <a:effectRef idx="0">
+              <a:schemeClr val="accent1"/>
+            </a:effectRef>
+            <a:fontRef idx="minor">
+              <a:schemeClr val="lt1"/>
+            </a:fontRef>
+          </p:style>
+          <p:txBody>
+            <a:bodyPr rtlCol="0" anchor="ctr"/>
+            <a:lstStyle/>
+            <a:p>
+              <a:pPr algn="ctr"/>
+              <a:endParaRPr lang="pt-BR"/>
+            </a:p>
+          </p:txBody>
+        </p:sp>
+        <p:sp>
+          <p:nvSpPr>
+            <p:cNvPr id="35" name="CaixaDeTexto 34">
+              <a:extLst>
+                <a:ext uri="{FF2B5EF4-FFF2-40B4-BE49-F238E27FC236}">
+                  <a16:creationId xmlns:a16="http://schemas.microsoft.com/office/drawing/2014/main" id="{26D36867-4978-35F4-2C32-2F9643C8CF21}"/>
+                </a:ext>
+              </a:extLst>
+            </p:cNvPr>
+            <p:cNvSpPr txBox="1"/>
+            <p:nvPr/>
+          </p:nvSpPr>
+          <p:spPr>
+            <a:xfrm>
+              <a:off x="1826636" y="4232084"/>
+              <a:ext cx="2778531" cy="1723549"/>
+            </a:xfrm>
+            <a:prstGeom prst="rect">
+              <a:avLst/>
+            </a:prstGeom>
+            <a:noFill/>
+          </p:spPr>
+          <p:txBody>
+            <a:bodyPr wrap="square">
+              <a:spAutoFit/>
+            </a:bodyPr>
+            <a:lstStyle/>
+            <a:p>
+              <a:pPr algn="ctr"/>
+              <a:r>
+                <a:rPr lang="pt-BR" sz="2400" b="1" dirty="0">
+                  <a:solidFill>
+                    <a:srgbClr val="B89560"/>
+                  </a:solidFill>
+                  <a:latin typeface="GT America Bold" panose="020B0604020202020204" charset="0"/>
+                  <a:cs typeface="Calibri" panose="020F0502020204030204" pitchFamily="34" charset="0"/>
+                </a:rPr>
+                <a:t>VALOR DE MERCADO</a:t>
+              </a:r>
+            </a:p>
+            <a:p>
+              <a:pPr algn="ctr"/>
+              <a:endParaRPr lang="pt-BR" sz="1000" b="1" u="sng" dirty="0">
+                <a:solidFill>
+                  <a:srgbClr val="B89560"/>
+                </a:solidFill>
+                <a:latin typeface="GT America Bold" panose="020B0604020202020204" charset="0"/>
+                <a:cs typeface="Calibri" panose="020F0502020204030204" pitchFamily="34" charset="0"/>
+              </a:endParaRPr>
+            </a:p>
+            <a:p>
+              <a:pPr algn="ctr"/>
+              <a:r>
+                <a:rPr lang="pt-BR" sz="1600" i="1" dirty="0">
+                  <a:solidFill>
+                    <a:srgbClr val="FFFFFF"/>
+                  </a:solidFill>
+                  <a:latin typeface="GT America Ultra Light" panose="020B0604020202020204" charset="0"/>
+                </a:rPr>
+                <a:t>O cerco fiscal se fecha sobre o valor real dos seus bens</a:t>
+              </a:r>
+            </a:p>
+          </p:txBody>
+        </p:sp>
+      </p:grpSp>
+      <p:grpSp>
+        <p:nvGrpSpPr>
+          <p:cNvPr id="8" name="Agrupar 7">
+            <a:extLst>
+              <a:ext uri="{FF2B5EF4-FFF2-40B4-BE49-F238E27FC236}">
+                <a16:creationId xmlns:a16="http://schemas.microsoft.com/office/drawing/2014/main" id="{2D9B98B9-5D3A-E2F0-BDF2-B0CA2455A419}"/>
+              </a:ext>
+            </a:extLst>
+          </p:cNvPr>
+          <p:cNvGrpSpPr/>
+          <p:nvPr/>
+        </p:nvGrpSpPr>
+        <p:grpSpPr>
+          <a:xfrm>
+            <a:off x="4131348" y="3975431"/>
+            <a:ext cx="2444628" cy="2337548"/>
+            <a:chOff x="5006907" y="3975765"/>
+            <a:chExt cx="3304356" cy="2337548"/>
+          </a:xfrm>
+        </p:grpSpPr>
+        <p:sp>
+          <p:nvSpPr>
+            <p:cNvPr id="31" name="Retângulo: Cantos Arredondados 30">
+              <a:extLst>
+                <a:ext uri="{FF2B5EF4-FFF2-40B4-BE49-F238E27FC236}">
+                  <a16:creationId xmlns:a16="http://schemas.microsoft.com/office/drawing/2014/main" id="{B20768FB-F060-C473-322C-468DE53029F1}"/>
+                </a:ext>
+              </a:extLst>
+            </p:cNvPr>
+            <p:cNvSpPr/>
+            <p:nvPr/>
+          </p:nvSpPr>
+          <p:spPr>
+            <a:xfrm>
+              <a:off x="5006907" y="3975765"/>
+              <a:ext cx="3304356" cy="2337548"/>
+            </a:xfrm>
+            <a:prstGeom prst="roundRect">
+              <a:avLst>
+                <a:gd name="adj" fmla="val 5801"/>
+              </a:avLst>
+            </a:prstGeom>
+            <a:solidFill>
+              <a:srgbClr val="FFFFFF">
+                <a:alpha val="20000"/>
+              </a:srgbClr>
+            </a:solidFill>
+          </p:spPr>
+          <p:style>
+            <a:lnRef idx="2">
+              <a:schemeClr val="accent1">
+                <a:shade val="15000"/>
+              </a:schemeClr>
+            </a:lnRef>
+            <a:fillRef idx="1">
+              <a:schemeClr val="accent1"/>
+            </a:fillRef>
+            <a:effectRef idx="0">
+              <a:schemeClr val="accent1"/>
+            </a:effectRef>
+            <a:fontRef idx="minor">
+              <a:schemeClr val="lt1"/>
+            </a:fontRef>
+          </p:style>
+          <p:txBody>
+            <a:bodyPr rtlCol="0" anchor="ctr"/>
+            <a:lstStyle/>
+            <a:p>
+              <a:pPr algn="ctr"/>
+              <a:endParaRPr lang="pt-BR"/>
+            </a:p>
+          </p:txBody>
+        </p:sp>
+        <p:sp>
+          <p:nvSpPr>
+            <p:cNvPr id="36" name="CaixaDeTexto 35">
+              <a:extLst>
+                <a:ext uri="{FF2B5EF4-FFF2-40B4-BE49-F238E27FC236}">
+                  <a16:creationId xmlns:a16="http://schemas.microsoft.com/office/drawing/2014/main" id="{C884245A-77C8-FBF2-35F7-947733ACB62F}"/>
+                </a:ext>
+              </a:extLst>
+            </p:cNvPr>
+            <p:cNvSpPr txBox="1"/>
+            <p:nvPr/>
+          </p:nvSpPr>
+          <p:spPr>
+            <a:xfrm>
+              <a:off x="5297752" y="4121875"/>
+              <a:ext cx="2645423" cy="2108269"/>
+            </a:xfrm>
+            <a:prstGeom prst="rect">
+              <a:avLst/>
+            </a:prstGeom>
+            <a:noFill/>
+          </p:spPr>
+          <p:txBody>
+            <a:bodyPr wrap="square">
+              <a:spAutoFit/>
+            </a:bodyPr>
+            <a:lstStyle/>
+            <a:p>
+              <a:pPr algn="ctr"/>
+              <a:r>
+                <a:rPr lang="pt-BR" sz="2800" b="1" dirty="0">
+                  <a:solidFill>
+                    <a:srgbClr val="B89560"/>
+                  </a:solidFill>
+                  <a:latin typeface="GT America Bold" panose="020B0604020202020204" charset="0"/>
+                  <a:cs typeface="Calibri" panose="020F0502020204030204" pitchFamily="34" charset="0"/>
+                </a:rPr>
+                <a:t>2% a 8% </a:t>
+              </a:r>
+            </a:p>
+            <a:p>
+              <a:pPr algn="ctr"/>
+              <a:r>
+                <a:rPr lang="pt-BR" sz="2800" b="1" dirty="0">
+                  <a:solidFill>
+                    <a:srgbClr val="B89560"/>
+                  </a:solidFill>
+                  <a:latin typeface="GT America Bold" panose="020B0604020202020204" charset="0"/>
+                  <a:cs typeface="Calibri" panose="020F0502020204030204" pitchFamily="34" charset="0"/>
+                </a:rPr>
+                <a:t>de ITCMD</a:t>
+              </a:r>
+            </a:p>
+            <a:p>
+              <a:pPr algn="ctr"/>
+              <a:endParaRPr lang="pt-BR" sz="1100" b="1" dirty="0">
+                <a:solidFill>
+                  <a:srgbClr val="B89560"/>
+                </a:solidFill>
+                <a:latin typeface="GT America Bold" panose="020B0604020202020204" charset="0"/>
+                <a:cs typeface="Calibri" panose="020F0502020204030204" pitchFamily="34" charset="0"/>
+              </a:endParaRPr>
+            </a:p>
+            <a:p>
+              <a:pPr algn="ctr"/>
+              <a:r>
+                <a:rPr lang="pt-BR" sz="1600" dirty="0">
+                  <a:solidFill>
+                    <a:srgbClr val="FFFFFF"/>
+                  </a:solidFill>
+                  <a:latin typeface="GT America Ultra Light" panose="020B0604020202020204" charset="0"/>
+                </a:rPr>
+                <a:t> </a:t>
+              </a:r>
+              <a:r>
+                <a:rPr lang="pt-BR" sz="1600" i="1" dirty="0">
+                  <a:solidFill>
+                    <a:srgbClr val="FFFFFF"/>
+                  </a:solidFill>
+                  <a:latin typeface="GT America Ultra Light" panose="020B0604020202020204" charset="0"/>
+                </a:rPr>
+                <a:t>Progressividade aprovada em âmbito federal — LC 227/2026</a:t>
+              </a:r>
+              <a:endParaRPr lang="pt-BR" sz="1600" dirty="0">
+                <a:solidFill>
+                  <a:srgbClr val="FFFFFF"/>
+                </a:solidFill>
+                <a:latin typeface="GT America Ultra Light" panose="020B0604020202020204" charset="0"/>
+              </a:endParaRPr>
+            </a:p>
+          </p:txBody>
+        </p:sp>
+      </p:grpSp>
+      <p:grpSp>
+        <p:nvGrpSpPr>
+          <p:cNvPr id="7" name="Agrupar 6">
+            <a:extLst>
+              <a:ext uri="{FF2B5EF4-FFF2-40B4-BE49-F238E27FC236}">
+                <a16:creationId xmlns:a16="http://schemas.microsoft.com/office/drawing/2014/main" id="{9855C121-5366-4329-D00C-81D56D181742}"/>
+              </a:ext>
+            </a:extLst>
+          </p:cNvPr>
+          <p:cNvGrpSpPr/>
+          <p:nvPr/>
+        </p:nvGrpSpPr>
+        <p:grpSpPr>
+          <a:xfrm>
+            <a:off x="6711417" y="3975431"/>
+            <a:ext cx="2444628" cy="2337548"/>
+            <a:chOff x="8425066" y="3975765"/>
+            <a:chExt cx="3304356" cy="2337548"/>
+          </a:xfrm>
+        </p:grpSpPr>
+        <p:sp>
+          <p:nvSpPr>
+            <p:cNvPr id="32" name="Retângulo: Cantos Arredondados 31">
+              <a:extLst>
+                <a:ext uri="{FF2B5EF4-FFF2-40B4-BE49-F238E27FC236}">
+                  <a16:creationId xmlns:a16="http://schemas.microsoft.com/office/drawing/2014/main" id="{B0656351-2DB8-C6D0-3FC4-434397C1367B}"/>
+                </a:ext>
+              </a:extLst>
+            </p:cNvPr>
+            <p:cNvSpPr/>
+            <p:nvPr/>
+          </p:nvSpPr>
+          <p:spPr>
+            <a:xfrm>
+              <a:off x="8425066" y="3975765"/>
+              <a:ext cx="3304356" cy="2337548"/>
+            </a:xfrm>
+            <a:prstGeom prst="roundRect">
+              <a:avLst>
+                <a:gd name="adj" fmla="val 5801"/>
+              </a:avLst>
+            </a:prstGeom>
+            <a:solidFill>
+              <a:srgbClr val="FFFFFF">
+                <a:alpha val="20000"/>
+              </a:srgbClr>
+            </a:solidFill>
+          </p:spPr>
+          <p:style>
+            <a:lnRef idx="2">
+              <a:schemeClr val="accent1">
+                <a:shade val="15000"/>
+              </a:schemeClr>
+            </a:lnRef>
+            <a:fillRef idx="1">
+              <a:schemeClr val="accent1"/>
+            </a:fillRef>
+            <a:effectRef idx="0">
+              <a:schemeClr val="accent1"/>
+            </a:effectRef>
+            <a:fontRef idx="minor">
+              <a:schemeClr val="lt1"/>
+            </a:fontRef>
+          </p:style>
+          <p:txBody>
+            <a:bodyPr rtlCol="0" anchor="ctr"/>
+            <a:lstStyle/>
+            <a:p>
+              <a:pPr algn="ctr"/>
+              <a:endParaRPr lang="pt-BR" dirty="0"/>
+            </a:p>
+          </p:txBody>
+        </p:sp>
+        <p:sp>
+          <p:nvSpPr>
+            <p:cNvPr id="39" name="CaixaDeTexto 38">
+              <a:extLst>
+                <a:ext uri="{FF2B5EF4-FFF2-40B4-BE49-F238E27FC236}">
+                  <a16:creationId xmlns:a16="http://schemas.microsoft.com/office/drawing/2014/main" id="{3F5F3099-A993-49F3-5FAB-FCC0684B1DF7}"/>
+                </a:ext>
+              </a:extLst>
+            </p:cNvPr>
+            <p:cNvSpPr txBox="1"/>
+            <p:nvPr/>
+          </p:nvSpPr>
+          <p:spPr>
+            <a:xfrm>
+              <a:off x="8498262" y="4121875"/>
+              <a:ext cx="3157962" cy="1938992"/>
+            </a:xfrm>
+            <a:prstGeom prst="rect">
+              <a:avLst/>
+            </a:prstGeom>
+            <a:noFill/>
+          </p:spPr>
+          <p:txBody>
+            <a:bodyPr wrap="square">
+              <a:spAutoFit/>
+            </a:bodyPr>
+            <a:lstStyle/>
+            <a:p>
+              <a:pPr algn="ctr"/>
+              <a:r>
+                <a:rPr lang="pt-BR" sz="3600" b="1" dirty="0">
+                  <a:solidFill>
+                    <a:srgbClr val="B89560"/>
+                  </a:solidFill>
+                  <a:latin typeface="GT America Bold" panose="020B0604020202020204" charset="0"/>
+                  <a:cs typeface="Calibri" panose="020F0502020204030204" pitchFamily="34" charset="0"/>
+                </a:rPr>
+                <a:t>16% </a:t>
+              </a:r>
+              <a:r>
+                <a:rPr lang="pt-BR" sz="2400" b="1" dirty="0">
+                  <a:solidFill>
+                    <a:srgbClr val="B89560"/>
+                  </a:solidFill>
+                  <a:latin typeface="GT America Bold" panose="020B0604020202020204" charset="0"/>
+                  <a:cs typeface="Calibri" panose="020F0502020204030204" pitchFamily="34" charset="0"/>
+                </a:rPr>
+                <a:t>de ITCMD</a:t>
+              </a:r>
+              <a:endParaRPr lang="pt-BR" sz="3600" b="1" dirty="0">
+                <a:solidFill>
+                  <a:srgbClr val="B89560"/>
+                </a:solidFill>
+                <a:latin typeface="GT America Bold" panose="020B0604020202020204" charset="0"/>
+                <a:cs typeface="Calibri" panose="020F0502020204030204" pitchFamily="34" charset="0"/>
+              </a:endParaRPr>
+            </a:p>
+            <a:p>
+              <a:pPr algn="ctr"/>
+              <a:endParaRPr lang="pt-BR" sz="1200" b="1" u="sng" dirty="0">
+                <a:solidFill>
+                  <a:srgbClr val="B89560"/>
+                </a:solidFill>
+                <a:latin typeface="GT America Bold" panose="020B0604020202020204" charset="0"/>
+                <a:cs typeface="Calibri" panose="020F0502020204030204" pitchFamily="34" charset="0"/>
+              </a:endParaRPr>
+            </a:p>
+            <a:p>
+              <a:pPr algn="ctr"/>
+              <a:r>
+                <a:rPr lang="pt-BR" sz="1600" dirty="0">
+                  <a:solidFill>
+                    <a:srgbClr val="FFFFFF"/>
+                  </a:solidFill>
+                  <a:latin typeface="GT America Ultra Light" panose="020B0604020202020204" charset="0"/>
+                  <a:cs typeface="Calibri" panose="020F0502020204030204" pitchFamily="34" charset="0"/>
+                </a:rPr>
+                <a:t>Projetos em tramitação propõem aumentar o limite atual</a:t>
+              </a:r>
+              <a:endParaRPr lang="pt-BR" sz="1600" dirty="0">
+                <a:solidFill>
+                  <a:srgbClr val="FFFFFF"/>
+                </a:solidFill>
+                <a:latin typeface="GT America Ultra Light" panose="020B0604020202020204" charset="0"/>
+              </a:endParaRPr>
+            </a:p>
+          </p:txBody>
+        </p:sp>
+      </p:grpSp>
+      <p:grpSp>
+        <p:nvGrpSpPr>
+          <p:cNvPr id="27" name="Agrupar 26">
+            <a:extLst>
+              <a:ext uri="{FF2B5EF4-FFF2-40B4-BE49-F238E27FC236}">
+                <a16:creationId xmlns:a16="http://schemas.microsoft.com/office/drawing/2014/main" id="{202C8338-4DAD-9380-6CE4-E5052E63DCF9}"/>
+              </a:ext>
+            </a:extLst>
+          </p:cNvPr>
+          <p:cNvGrpSpPr/>
+          <p:nvPr/>
+        </p:nvGrpSpPr>
+        <p:grpSpPr>
+          <a:xfrm>
+            <a:off x="9291487" y="3975431"/>
+            <a:ext cx="2444628" cy="2337548"/>
+            <a:chOff x="8425066" y="3975765"/>
+            <a:chExt cx="3304356" cy="2337548"/>
+          </a:xfrm>
+        </p:grpSpPr>
+        <p:sp>
+          <p:nvSpPr>
+            <p:cNvPr id="28" name="Retângulo: Cantos Arredondados 27">
+              <a:extLst>
+                <a:ext uri="{FF2B5EF4-FFF2-40B4-BE49-F238E27FC236}">
+                  <a16:creationId xmlns:a16="http://schemas.microsoft.com/office/drawing/2014/main" id="{11BA6312-9C5D-FB78-7507-D06A9BB02E74}"/>
+                </a:ext>
+              </a:extLst>
+            </p:cNvPr>
+            <p:cNvSpPr/>
+            <p:nvPr/>
+          </p:nvSpPr>
+          <p:spPr>
+            <a:xfrm>
+              <a:off x="8425066" y="3975765"/>
+              <a:ext cx="3304356" cy="2337548"/>
+            </a:xfrm>
+            <a:prstGeom prst="roundRect">
+              <a:avLst>
+                <a:gd name="adj" fmla="val 5801"/>
+              </a:avLst>
+            </a:prstGeom>
+            <a:solidFill>
+              <a:srgbClr val="FFFFFF">
+                <a:alpha val="20000"/>
+              </a:srgbClr>
+            </a:solidFill>
+          </p:spPr>
+          <p:style>
+            <a:lnRef idx="2">
+              <a:schemeClr val="accent1">
+                <a:shade val="15000"/>
+              </a:schemeClr>
+            </a:lnRef>
+            <a:fillRef idx="1">
+              <a:schemeClr val="accent1"/>
+            </a:fillRef>
+            <a:effectRef idx="0">
+              <a:schemeClr val="accent1"/>
+            </a:effectRef>
+            <a:fontRef idx="minor">
+              <a:schemeClr val="lt1"/>
+            </a:fontRef>
+          </p:style>
+          <p:txBody>
+            <a:bodyPr rtlCol="0" anchor="ctr"/>
+            <a:lstStyle/>
+            <a:p>
+              <a:pPr algn="ctr"/>
+              <a:endParaRPr lang="pt-BR" dirty="0"/>
+            </a:p>
+          </p:txBody>
+        </p:sp>
+        <p:sp>
+          <p:nvSpPr>
+            <p:cNvPr id="29" name="CaixaDeTexto 28">
+              <a:extLst>
+                <a:ext uri="{FF2B5EF4-FFF2-40B4-BE49-F238E27FC236}">
+                  <a16:creationId xmlns:a16="http://schemas.microsoft.com/office/drawing/2014/main" id="{0128D2F0-1029-F543-EC3C-E1D3B20AEE6D}"/>
+                </a:ext>
+              </a:extLst>
+            </p:cNvPr>
+            <p:cNvSpPr txBox="1"/>
+            <p:nvPr/>
+          </p:nvSpPr>
+          <p:spPr>
+            <a:xfrm>
+              <a:off x="8498262" y="4150969"/>
+              <a:ext cx="3157962" cy="1938992"/>
+            </a:xfrm>
+            <a:prstGeom prst="rect">
+              <a:avLst/>
+            </a:prstGeom>
+            <a:noFill/>
+          </p:spPr>
+          <p:txBody>
+            <a:bodyPr wrap="square">
+              <a:spAutoFit/>
+            </a:bodyPr>
+            <a:lstStyle/>
+            <a:p>
+              <a:pPr algn="ctr"/>
+              <a:r>
+                <a:rPr lang="pt-BR" sz="2400" b="1" dirty="0">
+                  <a:solidFill>
+                    <a:srgbClr val="B89560"/>
+                  </a:solidFill>
+                  <a:latin typeface="GT America Bold" panose="020B0604020202020204" charset="0"/>
+                  <a:cs typeface="Calibri" panose="020F0502020204030204" pitchFamily="34" charset="0"/>
+                </a:rPr>
+                <a:t>Previdência x</a:t>
+              </a:r>
+            </a:p>
+            <a:p>
+              <a:pPr algn="ctr"/>
+              <a:r>
+                <a:rPr lang="pt-BR" sz="2400" b="1" dirty="0">
+                  <a:solidFill>
+                    <a:srgbClr val="B89560"/>
+                  </a:solidFill>
+                  <a:latin typeface="GT America Bold" panose="020B0604020202020204" charset="0"/>
+                  <a:cs typeface="Calibri" panose="020F0502020204030204" pitchFamily="34" charset="0"/>
+                </a:rPr>
+                <a:t>ITCMD</a:t>
+              </a:r>
+              <a:endParaRPr lang="pt-BR" sz="1400" b="1" u="sng" dirty="0">
+                <a:solidFill>
+                  <a:srgbClr val="B89560"/>
+                </a:solidFill>
+                <a:latin typeface="GT America Bold" panose="020B0604020202020204" charset="0"/>
+                <a:cs typeface="Calibri" panose="020F0502020204030204" pitchFamily="34" charset="0"/>
+              </a:endParaRPr>
+            </a:p>
+            <a:p>
+              <a:pPr algn="ctr"/>
+              <a:r>
+                <a:rPr lang="pt-BR" dirty="0">
+                  <a:solidFill>
+                    <a:srgbClr val="FFFFFF"/>
+                  </a:solidFill>
+                  <a:latin typeface="GT America Ultra Light" panose="020B0604020202020204" charset="0"/>
+                  <a:cs typeface="Calibri" panose="020F0502020204030204" pitchFamily="34" charset="0"/>
+                </a:rPr>
+                <a:t>Diversas tentativas </a:t>
+              </a:r>
+              <a:r>
+                <a:rPr lang="pt-BR" b="1" dirty="0">
+                  <a:solidFill>
+                    <a:srgbClr val="FFFFFF"/>
+                  </a:solidFill>
+                  <a:latin typeface="GT America Ultra Light" panose="020B0604020202020204" charset="0"/>
+                  <a:cs typeface="Calibri" panose="020F0502020204030204" pitchFamily="34" charset="0"/>
+                </a:rPr>
+                <a:t>mal</a:t>
+              </a:r>
+              <a:r>
+                <a:rPr lang="pt-BR" dirty="0">
+                  <a:solidFill>
+                    <a:srgbClr val="FFFFFF"/>
+                  </a:solidFill>
+                  <a:latin typeface="GT America Ultra Light" panose="020B0604020202020204" charset="0"/>
+                  <a:cs typeface="Calibri" panose="020F0502020204030204" pitchFamily="34" charset="0"/>
+                </a:rPr>
+                <a:t> sucedidas de tributar a previdência</a:t>
+              </a:r>
+              <a:endParaRPr lang="pt-BR" dirty="0">
+                <a:solidFill>
+                  <a:srgbClr val="FFFFFF"/>
+                </a:solidFill>
+                <a:latin typeface="GT America Ultra Light" panose="020B0604020202020204" charset="0"/>
+              </a:endParaRPr>
+            </a:p>
+          </p:txBody>
+        </p:sp>
+      </p:grpSp>
     </p:spTree>
     <p:extLst>
       <p:ext uri="{BB962C8B-B14F-4D97-AF65-F5344CB8AC3E}">
@@ -7256,6 +8451,323 @@
       </p:transition>
     </mc:Fallback>
   </mc:AlternateContent>
+  <p:timing>
+    <p:tnLst>
+      <p:par>
+        <p:cTn id="1" dur="indefinite" restart="never" nodeType="tmRoot">
+          <p:childTnLst>
+            <p:seq concurrent="1" nextAc="seek">
+              <p:cTn id="2" dur="indefinite" nodeType="mainSeq">
+                <p:childTnLst>
+                  <p:par>
+                    <p:cTn id="3" fill="hold">
+                      <p:stCondLst>
+                        <p:cond delay="indefinite"/>
+                        <p:cond evt="onBegin" delay="0">
+                          <p:tn val="2"/>
+                        </p:cond>
+                      </p:stCondLst>
+                      <p:childTnLst>
+                        <p:par>
+                          <p:cTn id="4" fill="hold">
+                            <p:stCondLst>
+                              <p:cond delay="0"/>
+                            </p:stCondLst>
+                            <p:childTnLst>
+                              <p:par>
+                                <p:cTn id="5" presetID="42" presetClass="entr" presetSubtype="0" fill="hold" nodeType="withEffect">
+                                  <p:stCondLst>
+                                    <p:cond delay="0"/>
+                                  </p:stCondLst>
+                                  <p:childTnLst>
+                                    <p:set>
+                                      <p:cBhvr>
+                                        <p:cTn id="6" dur="1" fill="hold">
+                                          <p:stCondLst>
+                                            <p:cond delay="0"/>
+                                          </p:stCondLst>
+                                        </p:cTn>
+                                        <p:tgtEl>
+                                          <p:spTgt spid="3"/>
+                                        </p:tgtEl>
+                                        <p:attrNameLst>
+                                          <p:attrName>style.visibility</p:attrName>
+                                        </p:attrNameLst>
+                                      </p:cBhvr>
+                                      <p:to>
+                                        <p:strVal val="visible"/>
+                                      </p:to>
+                                    </p:set>
+                                    <p:animEffect transition="in" filter="fade">
+                                      <p:cBhvr>
+                                        <p:cTn id="7" dur="1000"/>
+                                        <p:tgtEl>
+                                          <p:spTgt spid="3"/>
+                                        </p:tgtEl>
+                                      </p:cBhvr>
+                                    </p:animEffect>
+                                    <p:anim calcmode="lin" valueType="num">
+                                      <p:cBhvr>
+                                        <p:cTn id="8" dur="1000" fill="hold"/>
+                                        <p:tgtEl>
+                                          <p:spTgt spid="3"/>
+                                        </p:tgtEl>
+                                        <p:attrNameLst>
+                                          <p:attrName>ppt_x</p:attrName>
+                                        </p:attrNameLst>
+                                      </p:cBhvr>
+                                      <p:tavLst>
+                                        <p:tav tm="0">
+                                          <p:val>
+                                            <p:strVal val="#ppt_x"/>
+                                          </p:val>
+                                        </p:tav>
+                                        <p:tav tm="100000">
+                                          <p:val>
+                                            <p:strVal val="#ppt_x"/>
+                                          </p:val>
+                                        </p:tav>
+                                      </p:tavLst>
+                                    </p:anim>
+                                    <p:anim calcmode="lin" valueType="num">
+                                      <p:cBhvr>
+                                        <p:cTn id="9" dur="1000" fill="hold"/>
+                                        <p:tgtEl>
+                                          <p:spTgt spid="3"/>
+                                        </p:tgtEl>
+                                        <p:attrNameLst>
+                                          <p:attrName>ppt_y</p:attrName>
+                                        </p:attrNameLst>
+                                      </p:cBhvr>
+                                      <p:tavLst>
+                                        <p:tav tm="0">
+                                          <p:val>
+                                            <p:strVal val="#ppt_y+.1"/>
+                                          </p:val>
+                                        </p:tav>
+                                        <p:tav tm="100000">
+                                          <p:val>
+                                            <p:strVal val="#ppt_y"/>
+                                          </p:val>
+                                        </p:tav>
+                                      </p:tavLst>
+                                    </p:anim>
+                                  </p:childTnLst>
+                                </p:cTn>
+                              </p:par>
+                            </p:childTnLst>
+                          </p:cTn>
+                        </p:par>
+                      </p:childTnLst>
+                    </p:cTn>
+                  </p:par>
+                  <p:par>
+                    <p:cTn id="10" fill="hold">
+                      <p:stCondLst>
+                        <p:cond delay="indefinite"/>
+                      </p:stCondLst>
+                      <p:childTnLst>
+                        <p:par>
+                          <p:cTn id="11" fill="hold">
+                            <p:stCondLst>
+                              <p:cond delay="0"/>
+                            </p:stCondLst>
+                            <p:childTnLst>
+                              <p:par>
+                                <p:cTn id="12" presetID="10" presetClass="entr" presetSubtype="0" fill="hold" nodeType="clickEffect">
+                                  <p:stCondLst>
+                                    <p:cond delay="0"/>
+                                  </p:stCondLst>
+                                  <p:childTnLst>
+                                    <p:set>
+                                      <p:cBhvr>
+                                        <p:cTn id="13" dur="1" fill="hold">
+                                          <p:stCondLst>
+                                            <p:cond delay="0"/>
+                                          </p:stCondLst>
+                                        </p:cTn>
+                                        <p:tgtEl>
+                                          <p:spTgt spid="5"/>
+                                        </p:tgtEl>
+                                        <p:attrNameLst>
+                                          <p:attrName>style.visibility</p:attrName>
+                                        </p:attrNameLst>
+                                      </p:cBhvr>
+                                      <p:to>
+                                        <p:strVal val="visible"/>
+                                      </p:to>
+                                    </p:set>
+                                    <p:animEffect transition="in" filter="fade">
+                                      <p:cBhvr>
+                                        <p:cTn id="14" dur="250"/>
+                                        <p:tgtEl>
+                                          <p:spTgt spid="5"/>
+                                        </p:tgtEl>
+                                      </p:cBhvr>
+                                    </p:animEffect>
+                                  </p:childTnLst>
+                                </p:cTn>
+                              </p:par>
+                            </p:childTnLst>
+                          </p:cTn>
+                        </p:par>
+                        <p:par>
+                          <p:cTn id="15" fill="hold">
+                            <p:stCondLst>
+                              <p:cond delay="250"/>
+                            </p:stCondLst>
+                            <p:childTnLst>
+                              <p:par>
+                                <p:cTn id="16" presetID="10" presetClass="entr" presetSubtype="0" fill="hold" nodeType="afterEffect">
+                                  <p:stCondLst>
+                                    <p:cond delay="0"/>
+                                  </p:stCondLst>
+                                  <p:childTnLst>
+                                    <p:set>
+                                      <p:cBhvr>
+                                        <p:cTn id="17" dur="1" fill="hold">
+                                          <p:stCondLst>
+                                            <p:cond delay="0"/>
+                                          </p:stCondLst>
+                                        </p:cTn>
+                                        <p:tgtEl>
+                                          <p:spTgt spid="8"/>
+                                        </p:tgtEl>
+                                        <p:attrNameLst>
+                                          <p:attrName>style.visibility</p:attrName>
+                                        </p:attrNameLst>
+                                      </p:cBhvr>
+                                      <p:to>
+                                        <p:strVal val="visible"/>
+                                      </p:to>
+                                    </p:set>
+                                    <p:animEffect transition="in" filter="fade">
+                                      <p:cBhvr>
+                                        <p:cTn id="18" dur="250"/>
+                                        <p:tgtEl>
+                                          <p:spTgt spid="8"/>
+                                        </p:tgtEl>
+                                      </p:cBhvr>
+                                    </p:animEffect>
+                                  </p:childTnLst>
+                                </p:cTn>
+                              </p:par>
+                            </p:childTnLst>
+                          </p:cTn>
+                        </p:par>
+                        <p:par>
+                          <p:cTn id="19" fill="hold">
+                            <p:stCondLst>
+                              <p:cond delay="500"/>
+                            </p:stCondLst>
+                            <p:childTnLst>
+                              <p:par>
+                                <p:cTn id="20" presetID="10" presetClass="entr" presetSubtype="0" fill="hold" nodeType="afterEffect">
+                                  <p:stCondLst>
+                                    <p:cond delay="0"/>
+                                  </p:stCondLst>
+                                  <p:childTnLst>
+                                    <p:set>
+                                      <p:cBhvr>
+                                        <p:cTn id="21" dur="1" fill="hold">
+                                          <p:stCondLst>
+                                            <p:cond delay="0"/>
+                                          </p:stCondLst>
+                                        </p:cTn>
+                                        <p:tgtEl>
+                                          <p:spTgt spid="7"/>
+                                        </p:tgtEl>
+                                        <p:attrNameLst>
+                                          <p:attrName>style.visibility</p:attrName>
+                                        </p:attrNameLst>
+                                      </p:cBhvr>
+                                      <p:to>
+                                        <p:strVal val="visible"/>
+                                      </p:to>
+                                    </p:set>
+                                    <p:animEffect transition="in" filter="fade">
+                                      <p:cBhvr>
+                                        <p:cTn id="22" dur="250"/>
+                                        <p:tgtEl>
+                                          <p:spTgt spid="7"/>
+                                        </p:tgtEl>
+                                      </p:cBhvr>
+                                    </p:animEffect>
+                                  </p:childTnLst>
+                                </p:cTn>
+                              </p:par>
+                            </p:childTnLst>
+                          </p:cTn>
+                        </p:par>
+                        <p:par>
+                          <p:cTn id="23" fill="hold">
+                            <p:stCondLst>
+                              <p:cond delay="750"/>
+                            </p:stCondLst>
+                            <p:childTnLst>
+                              <p:par>
+                                <p:cTn id="24" presetID="10" presetClass="entr" presetSubtype="0" fill="hold" nodeType="afterEffect">
+                                  <p:stCondLst>
+                                    <p:cond delay="0"/>
+                                  </p:stCondLst>
+                                  <p:childTnLst>
+                                    <p:set>
+                                      <p:cBhvr>
+                                        <p:cTn id="25" dur="1" fill="hold">
+                                          <p:stCondLst>
+                                            <p:cond delay="0"/>
+                                          </p:stCondLst>
+                                        </p:cTn>
+                                        <p:tgtEl>
+                                          <p:spTgt spid="27"/>
+                                        </p:tgtEl>
+                                        <p:attrNameLst>
+                                          <p:attrName>style.visibility</p:attrName>
+                                        </p:attrNameLst>
+                                      </p:cBhvr>
+                                      <p:to>
+                                        <p:strVal val="visible"/>
+                                      </p:to>
+                                    </p:set>
+                                    <p:animEffect transition="in" filter="fade">
+                                      <p:cBhvr>
+                                        <p:cTn id="26" dur="250"/>
+                                        <p:tgtEl>
+                                          <p:spTgt spid="27"/>
+                                        </p:tgtEl>
+                                      </p:cBhvr>
+                                    </p:animEffect>
+                                  </p:childTnLst>
+                                </p:cTn>
+                              </p:par>
+                            </p:childTnLst>
+                          </p:cTn>
+                        </p:par>
+                      </p:childTnLst>
+                    </p:cTn>
+                  </p:par>
+                </p:childTnLst>
+              </p:cTn>
+              <p:prevCondLst>
+                <p:cond evt="onPrev" delay="0">
+                  <p:tgtEl>
+                    <p:sldTgt/>
+                  </p:tgtEl>
+                </p:cond>
+              </p:prevCondLst>
+              <p:nextCondLst>
+                <p:cond evt="onNext" delay="0">
+                  <p:tgtEl>
+                    <p:sldTgt/>
+                  </p:tgtEl>
+                </p:cond>
+              </p:nextCondLst>
+            </p:seq>
+          </p:childTnLst>
+        </p:cTn>
+      </p:par>
+    </p:tnLst>
+  </p:timing>
 </p:sld>
 </file>
 

</xml_diff>

<commit_message>
feat: promover alterações aprovadas da apresentação
</commit_message>
<xml_diff>
--- a/public/assets/modelo-base.pptx
+++ b/public/assets/modelo-base.pptx
@@ -259,7 +259,7 @@
           <a:p>
             <a:fld id="{CCD5AC79-53BA-4A51-921C-8D0783828C7C}" type="datetimeFigureOut">
               <a:rPr lang="pt-BR" smtClean="0"/>
-              <a:t>17/07/2026</a:t>
+              <a:t>21/08/2026</a:t>
             </a:fld>
             <a:endParaRPr lang="pt-BR"/>
           </a:p>
@@ -436,7 +436,7 @@
           <a:p>
             <a:fld id="{FC8D2B75-57E3-4F00-A772-95EBE667B36A}" type="datetimeFigureOut">
               <a:rPr lang="pt-BR" smtClean="0"/>
-              <a:t>17/07/2026</a:t>
+              <a:t>21/08/2026</a:t>
             </a:fld>
             <a:endParaRPr lang="pt-BR"/>
           </a:p>
@@ -2208,7 +2208,7 @@
           <a:p>
             <a:fld id="{B11D4328-8647-44FB-B53F-BBD734F52BF8}" type="datetimeFigureOut">
               <a:rPr lang="pt-BR" smtClean="0"/>
-              <a:t>17/07/2026</a:t>
+              <a:t>21/08/2026</a:t>
             </a:fld>
             <a:endParaRPr lang="pt-BR"/>
           </a:p>
@@ -2428,7 +2428,7 @@
           <a:p>
             <a:fld id="{B2EA2344-E567-4C9F-AD93-44BDDB6AB8EC}" type="datetimeFigureOut">
               <a:rPr lang="pt-BR" smtClean="0"/>
-              <a:t>17/07/2026</a:t>
+              <a:t>21/08/2026</a:t>
             </a:fld>
             <a:endParaRPr lang="pt-BR"/>
           </a:p>
@@ -3798,7 +3798,7 @@
           <a:p>
             <a:fld id="{B11D4328-8647-44FB-B53F-BBD734F52BF8}" type="datetimeFigureOut">
               <a:rPr lang="pt-BR" smtClean="0"/>
-              <a:t>17/07/2026</a:t>
+              <a:t>21/08/2026</a:t>
             </a:fld>
             <a:endParaRPr lang="pt-BR"/>
           </a:p>
@@ -3996,7 +3996,7 @@
           <a:p>
             <a:fld id="{B11D4328-8647-44FB-B53F-BBD734F52BF8}" type="datetimeFigureOut">
               <a:rPr lang="pt-BR" smtClean="0"/>
-              <a:t>17/07/2026</a:t>
+              <a:t>21/08/2026</a:t>
             </a:fld>
             <a:endParaRPr lang="pt-BR"/>
           </a:p>
@@ -4240,7 +4240,7 @@
           <a:p>
             <a:fld id="{B11D4328-8647-44FB-B53F-BBD734F52BF8}" type="datetimeFigureOut">
               <a:rPr lang="pt-BR" smtClean="0"/>
-              <a:t>17/07/2026</a:t>
+              <a:t>21/08/2026</a:t>
             </a:fld>
             <a:endParaRPr lang="pt-BR"/>
           </a:p>
@@ -7561,55 +7561,29 @@
             <a:noFill/>
           </p:spPr>
           <p:txBody>
-            <a:bodyPr wrap="square" rtlCol="0">
-              <a:spAutoFit/>
+            <a:bodyPr wrap="square" rtlCol="0" anchor="ctr">
+              <a:noAutofit/>
             </a:bodyPr>
             <a:lstStyle/>
             <a:p>
               <a:pPr algn="ctr"/>
               <a:r>
-                <a:rPr lang="pt-BR" sz="3200" b="1" u="sng" dirty="0">
+                <a:rPr lang="pt-BR" sz="4350" b="1" u="sng">
                   <a:solidFill>
                     <a:srgbClr val="B89560"/>
                   </a:solidFill>
-                  <a:latin typeface="GT America Bold" panose="020B0604020202020204" charset="0"/>
+                  <a:latin typeface="GT America Bold" panose="020B0604020202020204"/>
                   <a:cs typeface="Calibri" panose="020F0502020204030204" pitchFamily="34" charset="0"/>
                 </a:rPr>
                 <a:t>R$ 3 BILHÕES DE REAIS</a:t>
               </a:r>
-            </a:p>
-            <a:p>
-              <a:pPr algn="ctr"/>
-              <a:endParaRPr lang="pt-BR" sz="1600" b="1" u="sng" dirty="0">
+              <a:endParaRPr lang="pt-BR" sz="4350" b="1" u="sng" dirty="0">
                 <a:solidFill>
-                  <a:srgbClr val="FFFFFF"/>
+                  <a:srgbClr val="B89560"/>
                 </a:solidFill>
-                <a:latin typeface="GT America Bold" panose="020B0604020202020204" charset="0"/>
+                <a:latin typeface="GT America Bold" panose="020B0604020202020204"/>
                 <a:cs typeface="Calibri" panose="020F0502020204030204" pitchFamily="34" charset="0"/>
               </a:endParaRPr>
-            </a:p>
-            <a:p>
-              <a:pPr algn="ctr"/>
-              <a:r>
-                <a:rPr lang="pt-BR" sz="2000" dirty="0">
-                  <a:solidFill>
-                    <a:srgbClr val="FFFFFF"/>
-                  </a:solidFill>
-                  <a:latin typeface="GT America Ultra Light" panose="020B0604020202020204" charset="0"/>
-                  <a:cs typeface="Calibri" panose="020F0502020204030204" pitchFamily="34" charset="0"/>
-                </a:rPr>
-                <a:t>ENCONTRAM-SE JUDICIALMENTE BLOQUEADOS EM CONTAS NA XP, AGUARDANDO A CONCLUSÃO DOS PROCESSOS DE </a:t>
-              </a:r>
-              <a:r>
-                <a:rPr lang="pt-BR" sz="2000" b="1" dirty="0">
-                  <a:solidFill>
-                    <a:srgbClr val="FFFFFF"/>
-                  </a:solidFill>
-                  <a:latin typeface="GT America Bold" panose="020B0604020202020204" charset="0"/>
-                  <a:cs typeface="Calibri" panose="020F0502020204030204" pitchFamily="34" charset="0"/>
-                </a:rPr>
-                <a:t>INVENTÁRIOS.</a:t>
-              </a:r>
             </a:p>
           </p:txBody>
         </p:sp>
@@ -7884,44 +7858,41 @@
             <a:noFill/>
           </p:spPr>
           <p:txBody>
-            <a:bodyPr wrap="square">
-              <a:spAutoFit/>
+            <a:bodyPr wrap="square" anchor="ctr">
+              <a:noAutofit/>
             </a:bodyPr>
             <a:lstStyle/>
             <a:p>
               <a:pPr algn="ctr"/>
               <a:r>
-                <a:rPr lang="pt-BR" sz="2400" b="1" dirty="0">
+                <a:rPr lang="pt-BR" sz="3300" b="1">
                   <a:solidFill>
                     <a:srgbClr val="B89560"/>
                   </a:solidFill>
-                  <a:latin typeface="GT America Bold" panose="020B0604020202020204" charset="0"/>
+                  <a:latin typeface="GT America Bold" panose="020B0604020202020204"/>
                   <a:cs typeface="Calibri" panose="020F0502020204030204" pitchFamily="34" charset="0"/>
                 </a:rPr>
-                <a:t>VALOR DE MERCADO</a:t>
+                <a:t>VALOR DE</a:t>
               </a:r>
             </a:p>
             <a:p>
               <a:pPr algn="ctr"/>
-              <a:endParaRPr lang="pt-BR" sz="1000" b="1" u="sng" dirty="0">
+              <a:r>
+                <a:rPr lang="pt-BR" sz="3300" b="1">
+                  <a:solidFill>
+                    <a:srgbClr val="B89560"/>
+                  </a:solidFill>
+                  <a:latin typeface="GT America Bold" panose="020B0604020202020204"/>
+                  <a:cs typeface="Calibri" panose="020F0502020204030204" pitchFamily="34" charset="0"/>
+                </a:rPr>
+                <a:t>MERCADO</a:t>
+              </a:r>
+              <a:endParaRPr lang="pt-BR" sz="3300" b="1" dirty="0">
                 <a:solidFill>
                   <a:srgbClr val="B89560"/>
                 </a:solidFill>
-                <a:latin typeface="GT America Bold" panose="020B0604020202020204" charset="0"/>
-                <a:cs typeface="Calibri" panose="020F0502020204030204" pitchFamily="34" charset="0"/>
+                <a:latin typeface="GT America Bold" panose="020B0604020202020204"/>
               </a:endParaRPr>
-            </a:p>
-            <a:p>
-              <a:pPr algn="ctr"/>
-              <a:r>
-                <a:rPr lang="pt-BR" sz="1600" i="1" dirty="0">
-                  <a:solidFill>
-                    <a:srgbClr val="FFFFFF"/>
-                  </a:solidFill>
-                  <a:latin typeface="GT America Ultra Light" panose="020B0604020202020204" charset="0"/>
-                </a:rPr>
-                <a:t>O cerco fiscal se fecha sobre o valor real dos seus bens</a:t>
-              </a:r>
             </a:p>
           </p:txBody>
         </p:sp>
@@ -8022,71 +7993,40 @@
             <a:noFill/>
           </p:spPr>
           <p:txBody>
-            <a:bodyPr wrap="square">
-              <a:spAutoFit/>
+            <a:bodyPr wrap="square" anchor="ctr">
+              <a:noAutofit/>
             </a:bodyPr>
             <a:lstStyle/>
             <a:p>
               <a:pPr algn="ctr"/>
               <a:r>
-                <a:rPr lang="pt-BR" sz="2800" b="1" dirty="0">
+                <a:rPr lang="pt-BR" sz="3375" b="1">
                   <a:solidFill>
                     <a:srgbClr val="B89560"/>
                   </a:solidFill>
-                  <a:latin typeface="GT America Bold" panose="020B0604020202020204" charset="0"/>
+                  <a:latin typeface="GT America Bold" panose="020B0604020202020204"/>
                   <a:cs typeface="Calibri" panose="020F0502020204030204" pitchFamily="34" charset="0"/>
                 </a:rPr>
-                <a:t>2% a 8% </a:t>
+                <a:t>2% a 8%</a:t>
               </a:r>
             </a:p>
             <a:p>
               <a:pPr algn="ctr"/>
               <a:r>
-                <a:rPr lang="pt-BR" sz="2800" b="1" dirty="0">
+                <a:rPr lang="pt-BR" sz="3375" b="1">
                   <a:solidFill>
                     <a:srgbClr val="B89560"/>
                   </a:solidFill>
-                  <a:latin typeface="GT America Bold" panose="020B0604020202020204" charset="0"/>
+                  <a:latin typeface="GT America Bold" panose="020B0604020202020204"/>
                   <a:cs typeface="Calibri" panose="020F0502020204030204" pitchFamily="34" charset="0"/>
                 </a:rPr>
                 <a:t>de ITCMD</a:t>
               </a:r>
-            </a:p>
-            <a:p>
-              <a:pPr algn="ctr"/>
-              <a:endParaRPr lang="pt-BR" sz="1100" b="1" dirty="0">
+              <a:endParaRPr lang="pt-BR" sz="3375" b="1" dirty="0">
                 <a:solidFill>
                   <a:srgbClr val="B89560"/>
                 </a:solidFill>
-                <a:latin typeface="GT America Bold" panose="020B0604020202020204" charset="0"/>
-                <a:cs typeface="Calibri" panose="020F0502020204030204" pitchFamily="34" charset="0"/>
-              </a:endParaRPr>
-            </a:p>
-            <a:p>
-              <a:pPr algn="ctr"/>
-              <a:r>
-                <a:rPr lang="pt-BR" sz="1600" dirty="0">
-                  <a:solidFill>
-                    <a:srgbClr val="FFFFFF"/>
-                  </a:solidFill>
-                  <a:latin typeface="GT America Ultra Light" panose="020B0604020202020204" charset="0"/>
-                </a:rPr>
-                <a:t> </a:t>
-              </a:r>
-              <a:r>
-                <a:rPr lang="pt-BR" sz="1600" i="1" dirty="0">
-                  <a:solidFill>
-                    <a:srgbClr val="FFFFFF"/>
-                  </a:solidFill>
-                  <a:latin typeface="GT America Ultra Light" panose="020B0604020202020204" charset="0"/>
-                </a:rPr>
-                <a:t>Progressividade aprovada em âmbito federal — LC 227/2026</a:t>
-              </a:r>
-              <a:endParaRPr lang="pt-BR" sz="1600" dirty="0">
-                <a:solidFill>
-                  <a:srgbClr val="FFFFFF"/>
-                </a:solidFill>
-                <a:latin typeface="GT America Ultra Light" panose="020B0604020202020204" charset="0"/>
+                <a:latin typeface="GT America Bold" panose="020B0604020202020204"/>
               </a:endParaRPr>
             </a:p>
           </p:txBody>
@@ -8188,67 +8128,40 @@
             <a:noFill/>
           </p:spPr>
           <p:txBody>
-            <a:bodyPr wrap="square">
-              <a:spAutoFit/>
+            <a:bodyPr wrap="square" anchor="ctr">
+              <a:noAutofit/>
             </a:bodyPr>
             <a:lstStyle/>
             <a:p>
               <a:pPr algn="ctr"/>
               <a:r>
-                <a:rPr lang="pt-BR" sz="3600" b="1" dirty="0">
+                <a:rPr lang="pt-BR" sz="3375" b="1">
                   <a:solidFill>
                     <a:srgbClr val="B89560"/>
                   </a:solidFill>
-                  <a:latin typeface="GT America Bold" panose="020B0604020202020204" charset="0"/>
+                  <a:latin typeface="GT America Bold" panose="020B0604020202020204"/>
                   <a:cs typeface="Calibri" panose="020F0502020204030204" pitchFamily="34" charset="0"/>
                 </a:rPr>
-                <a:t>16% </a:t>
+                <a:t>16%</a:t>
               </a:r>
+            </a:p>
+            <a:p>
+              <a:pPr algn="ctr"/>
               <a:r>
-                <a:rPr lang="pt-BR" sz="2400" b="1" dirty="0">
+                <a:rPr lang="pt-BR" sz="3375" b="1">
                   <a:solidFill>
                     <a:srgbClr val="B89560"/>
                   </a:solidFill>
-                  <a:latin typeface="GT America Bold" panose="020B0604020202020204" charset="0"/>
+                  <a:latin typeface="GT America Bold" panose="020B0604020202020204"/>
                   <a:cs typeface="Calibri" panose="020F0502020204030204" pitchFamily="34" charset="0"/>
                 </a:rPr>
                 <a:t>de ITCMD</a:t>
               </a:r>
-              <a:endParaRPr lang="pt-BR" sz="3600" b="1" dirty="0">
+              <a:endParaRPr lang="pt-BR" sz="3375" b="1" dirty="0">
                 <a:solidFill>
                   <a:srgbClr val="B89560"/>
                 </a:solidFill>
-                <a:latin typeface="GT America Bold" panose="020B0604020202020204" charset="0"/>
-                <a:cs typeface="Calibri" panose="020F0502020204030204" pitchFamily="34" charset="0"/>
-              </a:endParaRPr>
-            </a:p>
-            <a:p>
-              <a:pPr algn="ctr"/>
-              <a:endParaRPr lang="pt-BR" sz="1200" b="1" u="sng" dirty="0">
-                <a:solidFill>
-                  <a:srgbClr val="B89560"/>
-                </a:solidFill>
-                <a:latin typeface="GT America Bold" panose="020B0604020202020204" charset="0"/>
-                <a:cs typeface="Calibri" panose="020F0502020204030204" pitchFamily="34" charset="0"/>
-              </a:endParaRPr>
-            </a:p>
-            <a:p>
-              <a:pPr algn="ctr"/>
-              <a:r>
-                <a:rPr lang="pt-BR" sz="1600" dirty="0">
-                  <a:solidFill>
-                    <a:srgbClr val="FFFFFF"/>
-                  </a:solidFill>
-                  <a:latin typeface="GT America Ultra Light" panose="020B0604020202020204" charset="0"/>
-                  <a:cs typeface="Calibri" panose="020F0502020204030204" pitchFamily="34" charset="0"/>
-                </a:rPr>
-                <a:t>Projetos em tramitação propõem aumentar o limite atual</a:t>
-              </a:r>
-              <a:endParaRPr lang="pt-BR" sz="1600" dirty="0">
-                <a:solidFill>
-                  <a:srgbClr val="FFFFFF"/>
-                </a:solidFill>
-                <a:latin typeface="GT America Ultra Light" panose="020B0604020202020204" charset="0"/>
+                <a:latin typeface="GT America Bold" panose="020B0604020202020204"/>
               </a:endParaRPr>
             </a:p>
           </p:txBody>
@@ -8350,18 +8263,18 @@
             <a:noFill/>
           </p:spPr>
           <p:txBody>
-            <a:bodyPr wrap="square">
-              <a:spAutoFit/>
+            <a:bodyPr wrap="square" anchor="ctr">
+              <a:noAutofit/>
             </a:bodyPr>
             <a:lstStyle/>
             <a:p>
               <a:pPr algn="ctr"/>
               <a:r>
-                <a:rPr lang="pt-BR" sz="2400" b="1" dirty="0">
+                <a:rPr lang="pt-BR" sz="2625" b="1">
                   <a:solidFill>
                     <a:srgbClr val="B89560"/>
                   </a:solidFill>
-                  <a:latin typeface="GT America Bold" panose="020B0604020202020204" charset="0"/>
+                  <a:latin typeface="GT America Bold" panose="020B0604020202020204"/>
                   <a:cs typeface="Calibri" panose="020F0502020204030204" pitchFamily="34" charset="0"/>
                 </a:rPr>
                 <a:t>Previdência x</a:t>
@@ -8370,60 +8283,20 @@
             <a:p>
               <a:pPr algn="ctr"/>
               <a:r>
-                <a:rPr lang="pt-BR" sz="2400" b="1" dirty="0">
+                <a:rPr lang="pt-BR" sz="2625" b="1">
                   <a:solidFill>
                     <a:srgbClr val="B89560"/>
                   </a:solidFill>
-                  <a:latin typeface="GT America Bold" panose="020B0604020202020204" charset="0"/>
+                  <a:latin typeface="GT America Bold" panose="020B0604020202020204"/>
                   <a:cs typeface="Calibri" panose="020F0502020204030204" pitchFamily="34" charset="0"/>
                 </a:rPr>
                 <a:t>ITCMD</a:t>
               </a:r>
-              <a:endParaRPr lang="pt-BR" sz="1400" b="1" u="sng" dirty="0">
+              <a:endParaRPr lang="pt-BR" sz="2625" b="1" dirty="0">
                 <a:solidFill>
                   <a:srgbClr val="B89560"/>
                 </a:solidFill>
-                <a:latin typeface="GT America Bold" panose="020B0604020202020204" charset="0"/>
-                <a:cs typeface="Calibri" panose="020F0502020204030204" pitchFamily="34" charset="0"/>
-              </a:endParaRPr>
-            </a:p>
-            <a:p>
-              <a:pPr algn="ctr"/>
-              <a:r>
-                <a:rPr lang="pt-BR" dirty="0">
-                  <a:solidFill>
-                    <a:srgbClr val="FFFFFF"/>
-                  </a:solidFill>
-                  <a:latin typeface="GT America Ultra Light" panose="020B0604020202020204" charset="0"/>
-                  <a:cs typeface="Calibri" panose="020F0502020204030204" pitchFamily="34" charset="0"/>
-                </a:rPr>
-                <a:t>Diversas tentativas </a:t>
-              </a:r>
-              <a:r>
-                <a:rPr lang="pt-BR" b="1" dirty="0">
-                  <a:solidFill>
-                    <a:srgbClr val="FFFFFF"/>
-                  </a:solidFill>
-                  <a:latin typeface="GT America Ultra Light" panose="020B0604020202020204" charset="0"/>
-                  <a:cs typeface="Calibri" panose="020F0502020204030204" pitchFamily="34" charset="0"/>
-                </a:rPr>
-                <a:t>mal</a:t>
-              </a:r>
-              <a:r>
-                <a:rPr lang="pt-BR" dirty="0">
-                  <a:solidFill>
-                    <a:srgbClr val="FFFFFF"/>
-                  </a:solidFill>
-                  <a:latin typeface="GT America Ultra Light" panose="020B0604020202020204" charset="0"/>
-                  <a:cs typeface="Calibri" panose="020F0502020204030204" pitchFamily="34" charset="0"/>
-                </a:rPr>
-                <a:t> sucedidas de tributar a previdência</a:t>
-              </a:r>
-              <a:endParaRPr lang="pt-BR" dirty="0">
-                <a:solidFill>
-                  <a:srgbClr val="FFFFFF"/>
-                </a:solidFill>
-                <a:latin typeface="GT America Ultra Light" panose="020B0604020202020204" charset="0"/>
+                <a:latin typeface="GT America Bold" panose="020B0604020202020204"/>
               </a:endParaRPr>
             </a:p>
           </p:txBody>

</xml_diff>